<commit_message>
Hackaton: capa com o banner oficial e todos os realizadores no rodapé
Co-Authored-By: Claude Opus 5.5 <noreply@anthropic.com>
Claude-Session: https://claude.ai/code/session_01NGPBviRxuMstJ41FmEKRdC
</commit_message>
<xml_diff>
--- a/Hackaton/slides/Autotec_futurista.pptx
+++ b/Hackaton/slides/Autotec_futurista.pptx
@@ -10,6 +10,7 @@
     <p:sldId id="258" r:id="rId9"/>
     <p:sldId id="259" r:id="rId10"/>
     <p:sldId id="260" r:id="rId11"/>
+    <p:sldId id="261" r:id="rId12"/>
   </p:sldIdLst>
   <p:sldSz cx="9144000" cy="5143500" type="screen4x3"/>
   <p:notesSz cx="6858000" cy="9144000"/>
@@ -709,14 +710,6 @@
 <file path=ppt/slides/slide1.xml><?xml version="1.0" encoding="utf-8"?>
 <p:sld xmlns:a="http://schemas.openxmlformats.org/drawingml/2006/main" xmlns:p="http://schemas.openxmlformats.org/presentationml/2006/main" xmlns:r="http://schemas.openxmlformats.org/officeDocument/2006/relationships">
   <p:cSld>
-    <p:bg>
-      <p:bgPr>
-        <a:solidFill>
-          <a:srgbClr val="05030D"/>
-        </a:solidFill>
-        <a:effectLst/>
-      </p:bgPr>
-    </p:bg>
     <p:spTree>
       <p:nvGrpSpPr>
         <p:cNvPr id="1" name=""/>
@@ -724,1421 +717,30 @@
         <p:nvPr/>
       </p:nvGrpSpPr>
       <p:grpSpPr/>
-      <p:sp>
-        <p:nvSpPr>
-          <p:cNvPr id="2" name="Oval 1"/>
-          <p:cNvSpPr/>
-          <p:nvPr/>
-        </p:nvSpPr>
-        <p:spPr>
-          <a:xfrm>
-            <a:off x="-1371600" y="-1645920"/>
-            <a:ext cx="5029200" cy="4114800"/>
-          </a:xfrm>
-          <a:prstGeom prst="ellipse">
-            <a:avLst/>
-          </a:prstGeom>
-          <a:solidFill>
-            <a:srgbClr val="7B2CFF">
-              <a:alpha val="22000"/>
-            </a:srgbClr>
-          </a:solidFill>
-          <a:ln>
-            <a:noFill/>
-          </a:ln>
-          <a:effectLst/>
-        </p:spPr>
-        <p:style>
-          <a:lnRef idx="1">
-            <a:schemeClr val="accent1"/>
-          </a:lnRef>
-          <a:fillRef idx="3">
-            <a:schemeClr val="accent1"/>
-          </a:fillRef>
-          <a:effectRef idx="2">
-            <a:schemeClr val="accent1"/>
-          </a:effectRef>
-          <a:fontRef idx="minor">
-            <a:schemeClr val="lt1"/>
-          </a:fontRef>
-        </p:style>
-        <p:txBody>
-          <a:bodyPr rtlCol="0" anchor="ctr"/>
-          <a:lstStyle/>
-          <a:p>
-            <a:pPr algn="ctr"/>
-          </a:p>
-        </p:txBody>
-      </p:sp>
-      <p:sp>
-        <p:nvSpPr>
-          <p:cNvPr id="3" name="Oval 2"/>
-          <p:cNvSpPr/>
-          <p:nvPr/>
-        </p:nvSpPr>
-        <p:spPr>
-          <a:xfrm>
-            <a:off x="6400800" y="3108960"/>
-            <a:ext cx="4114800" cy="3200400"/>
-          </a:xfrm>
-          <a:prstGeom prst="ellipse">
-            <a:avLst/>
-          </a:prstGeom>
-          <a:solidFill>
-            <a:srgbClr val="FF2BD6">
-              <a:alpha val="14000"/>
-            </a:srgbClr>
-          </a:solidFill>
-          <a:ln>
-            <a:noFill/>
-          </a:ln>
-          <a:effectLst/>
-        </p:spPr>
-        <p:style>
-          <a:lnRef idx="1">
-            <a:schemeClr val="accent1"/>
-          </a:lnRef>
-          <a:fillRef idx="3">
-            <a:schemeClr val="accent1"/>
-          </a:fillRef>
-          <a:effectRef idx="2">
-            <a:schemeClr val="accent1"/>
-          </a:effectRef>
-          <a:fontRef idx="minor">
-            <a:schemeClr val="lt1"/>
-          </a:fontRef>
-        </p:style>
-        <p:txBody>
-          <a:bodyPr rtlCol="0" anchor="ctr"/>
-          <a:lstStyle/>
-          <a:p>
-            <a:pPr algn="ctr"/>
-          </a:p>
-        </p:txBody>
-      </p:sp>
-      <p:sp>
-        <p:nvSpPr>
-          <p:cNvPr id="4" name="Rectangle 3"/>
-          <p:cNvSpPr/>
-          <p:nvPr/>
-        </p:nvSpPr>
-        <p:spPr>
-          <a:xfrm>
-            <a:off x="914400" y="0"/>
-            <a:ext cx="9144" cy="5143500"/>
-          </a:xfrm>
-          <a:prstGeom prst="rect">
-            <a:avLst/>
-          </a:prstGeom>
-          <a:solidFill>
-            <a:srgbClr val="22E6FF">
-              <a:alpha val="6000"/>
-            </a:srgbClr>
-          </a:solidFill>
-          <a:ln>
-            <a:noFill/>
-          </a:ln>
-          <a:effectLst/>
-        </p:spPr>
-        <p:style>
-          <a:lnRef idx="1">
-            <a:schemeClr val="accent1"/>
-          </a:lnRef>
-          <a:fillRef idx="3">
-            <a:schemeClr val="accent1"/>
-          </a:fillRef>
-          <a:effectRef idx="2">
-            <a:schemeClr val="accent1"/>
-          </a:effectRef>
-          <a:fontRef idx="minor">
-            <a:schemeClr val="lt1"/>
-          </a:fontRef>
-        </p:style>
-        <p:txBody>
-          <a:bodyPr rtlCol="0" anchor="ctr"/>
-          <a:lstStyle/>
-          <a:p>
-            <a:pPr algn="ctr"/>
-          </a:p>
-        </p:txBody>
-      </p:sp>
-      <p:sp>
-        <p:nvSpPr>
-          <p:cNvPr id="5" name="Rectangle 4"/>
-          <p:cNvSpPr/>
-          <p:nvPr/>
-        </p:nvSpPr>
-        <p:spPr>
-          <a:xfrm>
-            <a:off x="1828800" y="0"/>
-            <a:ext cx="9144" cy="5143500"/>
-          </a:xfrm>
-          <a:prstGeom prst="rect">
-            <a:avLst/>
-          </a:prstGeom>
-          <a:solidFill>
-            <a:srgbClr val="22E6FF">
-              <a:alpha val="6000"/>
-            </a:srgbClr>
-          </a:solidFill>
-          <a:ln>
-            <a:noFill/>
-          </a:ln>
-          <a:effectLst/>
-        </p:spPr>
-        <p:style>
-          <a:lnRef idx="1">
-            <a:schemeClr val="accent1"/>
-          </a:lnRef>
-          <a:fillRef idx="3">
-            <a:schemeClr val="accent1"/>
-          </a:fillRef>
-          <a:effectRef idx="2">
-            <a:schemeClr val="accent1"/>
-          </a:effectRef>
-          <a:fontRef idx="minor">
-            <a:schemeClr val="lt1"/>
-          </a:fontRef>
-        </p:style>
-        <p:txBody>
-          <a:bodyPr rtlCol="0" anchor="ctr"/>
-          <a:lstStyle/>
-          <a:p>
-            <a:pPr algn="ctr"/>
-          </a:p>
-        </p:txBody>
-      </p:sp>
-      <p:sp>
-        <p:nvSpPr>
-          <p:cNvPr id="6" name="Rectangle 5"/>
-          <p:cNvSpPr/>
-          <p:nvPr/>
-        </p:nvSpPr>
-        <p:spPr>
-          <a:xfrm>
-            <a:off x="2743200" y="0"/>
-            <a:ext cx="9144" cy="5143500"/>
-          </a:xfrm>
-          <a:prstGeom prst="rect">
-            <a:avLst/>
-          </a:prstGeom>
-          <a:solidFill>
-            <a:srgbClr val="22E6FF">
-              <a:alpha val="6000"/>
-            </a:srgbClr>
-          </a:solidFill>
-          <a:ln>
-            <a:noFill/>
-          </a:ln>
-          <a:effectLst/>
-        </p:spPr>
-        <p:style>
-          <a:lnRef idx="1">
-            <a:schemeClr val="accent1"/>
-          </a:lnRef>
-          <a:fillRef idx="3">
-            <a:schemeClr val="accent1"/>
-          </a:fillRef>
-          <a:effectRef idx="2">
-            <a:schemeClr val="accent1"/>
-          </a:effectRef>
-          <a:fontRef idx="minor">
-            <a:schemeClr val="lt1"/>
-          </a:fontRef>
-        </p:style>
-        <p:txBody>
-          <a:bodyPr rtlCol="0" anchor="ctr"/>
-          <a:lstStyle/>
-          <a:p>
-            <a:pPr algn="ctr"/>
-          </a:p>
-        </p:txBody>
-      </p:sp>
-      <p:sp>
-        <p:nvSpPr>
-          <p:cNvPr id="7" name="Rectangle 6"/>
-          <p:cNvSpPr/>
-          <p:nvPr/>
-        </p:nvSpPr>
-        <p:spPr>
-          <a:xfrm>
-            <a:off x="3657600" y="0"/>
-            <a:ext cx="9144" cy="5143500"/>
-          </a:xfrm>
-          <a:prstGeom prst="rect">
-            <a:avLst/>
-          </a:prstGeom>
-          <a:solidFill>
-            <a:srgbClr val="22E6FF">
-              <a:alpha val="6000"/>
-            </a:srgbClr>
-          </a:solidFill>
-          <a:ln>
-            <a:noFill/>
-          </a:ln>
-          <a:effectLst/>
-        </p:spPr>
-        <p:style>
-          <a:lnRef idx="1">
-            <a:schemeClr val="accent1"/>
-          </a:lnRef>
-          <a:fillRef idx="3">
-            <a:schemeClr val="accent1"/>
-          </a:fillRef>
-          <a:effectRef idx="2">
-            <a:schemeClr val="accent1"/>
-          </a:effectRef>
-          <a:fontRef idx="minor">
-            <a:schemeClr val="lt1"/>
-          </a:fontRef>
-        </p:style>
-        <p:txBody>
-          <a:bodyPr rtlCol="0" anchor="ctr"/>
-          <a:lstStyle/>
-          <a:p>
-            <a:pPr algn="ctr"/>
-          </a:p>
-        </p:txBody>
-      </p:sp>
-      <p:sp>
-        <p:nvSpPr>
-          <p:cNvPr id="8" name="Rectangle 7"/>
-          <p:cNvSpPr/>
-          <p:nvPr/>
-        </p:nvSpPr>
-        <p:spPr>
-          <a:xfrm>
-            <a:off x="4572000" y="0"/>
-            <a:ext cx="9144" cy="5143500"/>
-          </a:xfrm>
-          <a:prstGeom prst="rect">
-            <a:avLst/>
-          </a:prstGeom>
-          <a:solidFill>
-            <a:srgbClr val="22E6FF">
-              <a:alpha val="6000"/>
-            </a:srgbClr>
-          </a:solidFill>
-          <a:ln>
-            <a:noFill/>
-          </a:ln>
-          <a:effectLst/>
-        </p:spPr>
-        <p:style>
-          <a:lnRef idx="1">
-            <a:schemeClr val="accent1"/>
-          </a:lnRef>
-          <a:fillRef idx="3">
-            <a:schemeClr val="accent1"/>
-          </a:fillRef>
-          <a:effectRef idx="2">
-            <a:schemeClr val="accent1"/>
-          </a:effectRef>
-          <a:fontRef idx="minor">
-            <a:schemeClr val="lt1"/>
-          </a:fontRef>
-        </p:style>
-        <p:txBody>
-          <a:bodyPr rtlCol="0" anchor="ctr"/>
-          <a:lstStyle/>
-          <a:p>
-            <a:pPr algn="ctr"/>
-          </a:p>
-        </p:txBody>
-      </p:sp>
-      <p:sp>
-        <p:nvSpPr>
-          <p:cNvPr id="9" name="Rectangle 8"/>
-          <p:cNvSpPr/>
-          <p:nvPr/>
-        </p:nvSpPr>
-        <p:spPr>
-          <a:xfrm>
-            <a:off x="5486400" y="0"/>
-            <a:ext cx="9144" cy="5143500"/>
-          </a:xfrm>
-          <a:prstGeom prst="rect">
-            <a:avLst/>
-          </a:prstGeom>
-          <a:solidFill>
-            <a:srgbClr val="22E6FF">
-              <a:alpha val="6000"/>
-            </a:srgbClr>
-          </a:solidFill>
-          <a:ln>
-            <a:noFill/>
-          </a:ln>
-          <a:effectLst/>
-        </p:spPr>
-        <p:style>
-          <a:lnRef idx="1">
-            <a:schemeClr val="accent1"/>
-          </a:lnRef>
-          <a:fillRef idx="3">
-            <a:schemeClr val="accent1"/>
-          </a:fillRef>
-          <a:effectRef idx="2">
-            <a:schemeClr val="accent1"/>
-          </a:effectRef>
-          <a:fontRef idx="minor">
-            <a:schemeClr val="lt1"/>
-          </a:fontRef>
-        </p:style>
-        <p:txBody>
-          <a:bodyPr rtlCol="0" anchor="ctr"/>
-          <a:lstStyle/>
-          <a:p>
-            <a:pPr algn="ctr"/>
-          </a:p>
-        </p:txBody>
-      </p:sp>
-      <p:sp>
-        <p:nvSpPr>
-          <p:cNvPr id="10" name="Rectangle 9"/>
-          <p:cNvSpPr/>
-          <p:nvPr/>
-        </p:nvSpPr>
-        <p:spPr>
-          <a:xfrm>
-            <a:off x="6400800" y="0"/>
-            <a:ext cx="9144" cy="5143500"/>
-          </a:xfrm>
-          <a:prstGeom prst="rect">
-            <a:avLst/>
-          </a:prstGeom>
-          <a:solidFill>
-            <a:srgbClr val="22E6FF">
-              <a:alpha val="6000"/>
-            </a:srgbClr>
-          </a:solidFill>
-          <a:ln>
-            <a:noFill/>
-          </a:ln>
-          <a:effectLst/>
-        </p:spPr>
-        <p:style>
-          <a:lnRef idx="1">
-            <a:schemeClr val="accent1"/>
-          </a:lnRef>
-          <a:fillRef idx="3">
-            <a:schemeClr val="accent1"/>
-          </a:fillRef>
-          <a:effectRef idx="2">
-            <a:schemeClr val="accent1"/>
-          </a:effectRef>
-          <a:fontRef idx="minor">
-            <a:schemeClr val="lt1"/>
-          </a:fontRef>
-        </p:style>
-        <p:txBody>
-          <a:bodyPr rtlCol="0" anchor="ctr"/>
-          <a:lstStyle/>
-          <a:p>
-            <a:pPr algn="ctr"/>
-          </a:p>
-        </p:txBody>
-      </p:sp>
-      <p:sp>
-        <p:nvSpPr>
-          <p:cNvPr id="11" name="Rectangle 10"/>
-          <p:cNvSpPr/>
-          <p:nvPr/>
-        </p:nvSpPr>
-        <p:spPr>
-          <a:xfrm>
-            <a:off x="7315200" y="0"/>
-            <a:ext cx="9144" cy="5143500"/>
-          </a:xfrm>
-          <a:prstGeom prst="rect">
-            <a:avLst/>
-          </a:prstGeom>
-          <a:solidFill>
-            <a:srgbClr val="22E6FF">
-              <a:alpha val="6000"/>
-            </a:srgbClr>
-          </a:solidFill>
-          <a:ln>
-            <a:noFill/>
-          </a:ln>
-          <a:effectLst/>
-        </p:spPr>
-        <p:style>
-          <a:lnRef idx="1">
-            <a:schemeClr val="accent1"/>
-          </a:lnRef>
-          <a:fillRef idx="3">
-            <a:schemeClr val="accent1"/>
-          </a:fillRef>
-          <a:effectRef idx="2">
-            <a:schemeClr val="accent1"/>
-          </a:effectRef>
-          <a:fontRef idx="minor">
-            <a:schemeClr val="lt1"/>
-          </a:fontRef>
-        </p:style>
-        <p:txBody>
-          <a:bodyPr rtlCol="0" anchor="ctr"/>
-          <a:lstStyle/>
-          <a:p>
-            <a:pPr algn="ctr"/>
-          </a:p>
-        </p:txBody>
-      </p:sp>
-      <p:sp>
-        <p:nvSpPr>
-          <p:cNvPr id="12" name="Rectangle 11"/>
-          <p:cNvSpPr/>
-          <p:nvPr/>
-        </p:nvSpPr>
-        <p:spPr>
-          <a:xfrm>
-            <a:off x="8229600" y="0"/>
-            <a:ext cx="9144" cy="5143500"/>
-          </a:xfrm>
-          <a:prstGeom prst="rect">
-            <a:avLst/>
-          </a:prstGeom>
-          <a:solidFill>
-            <a:srgbClr val="22E6FF">
-              <a:alpha val="6000"/>
-            </a:srgbClr>
-          </a:solidFill>
-          <a:ln>
-            <a:noFill/>
-          </a:ln>
-          <a:effectLst/>
-        </p:spPr>
-        <p:style>
-          <a:lnRef idx="1">
-            <a:schemeClr val="accent1"/>
-          </a:lnRef>
-          <a:fillRef idx="3">
-            <a:schemeClr val="accent1"/>
-          </a:fillRef>
-          <a:effectRef idx="2">
-            <a:schemeClr val="accent1"/>
-          </a:effectRef>
-          <a:fontRef idx="minor">
-            <a:schemeClr val="lt1"/>
-          </a:fontRef>
-        </p:style>
-        <p:txBody>
-          <a:bodyPr rtlCol="0" anchor="ctr"/>
-          <a:lstStyle/>
-          <a:p>
-            <a:pPr algn="ctr"/>
-          </a:p>
-        </p:txBody>
-      </p:sp>
-      <p:sp>
-        <p:nvSpPr>
-          <p:cNvPr id="13" name="Rectangle 12"/>
-          <p:cNvSpPr/>
-          <p:nvPr/>
-        </p:nvSpPr>
-        <p:spPr>
-          <a:xfrm>
-            <a:off x="0" y="914400"/>
-            <a:ext cx="9144000" cy="9144"/>
-          </a:xfrm>
-          <a:prstGeom prst="rect">
-            <a:avLst/>
-          </a:prstGeom>
-          <a:solidFill>
-            <a:srgbClr val="22E6FF">
-              <a:alpha val="6000"/>
-            </a:srgbClr>
-          </a:solidFill>
-          <a:ln>
-            <a:noFill/>
-          </a:ln>
-          <a:effectLst/>
-        </p:spPr>
-        <p:style>
-          <a:lnRef idx="1">
-            <a:schemeClr val="accent1"/>
-          </a:lnRef>
-          <a:fillRef idx="3">
-            <a:schemeClr val="accent1"/>
-          </a:fillRef>
-          <a:effectRef idx="2">
-            <a:schemeClr val="accent1"/>
-          </a:effectRef>
-          <a:fontRef idx="minor">
-            <a:schemeClr val="lt1"/>
-          </a:fontRef>
-        </p:style>
-        <p:txBody>
-          <a:bodyPr rtlCol="0" anchor="ctr"/>
-          <a:lstStyle/>
-          <a:p>
-            <a:pPr algn="ctr"/>
-          </a:p>
-        </p:txBody>
-      </p:sp>
-      <p:sp>
-        <p:nvSpPr>
-          <p:cNvPr id="14" name="Rectangle 13"/>
-          <p:cNvSpPr/>
-          <p:nvPr/>
-        </p:nvSpPr>
-        <p:spPr>
-          <a:xfrm>
-            <a:off x="0" y="1828800"/>
-            <a:ext cx="9144000" cy="9144"/>
-          </a:xfrm>
-          <a:prstGeom prst="rect">
-            <a:avLst/>
-          </a:prstGeom>
-          <a:solidFill>
-            <a:srgbClr val="22E6FF">
-              <a:alpha val="6000"/>
-            </a:srgbClr>
-          </a:solidFill>
-          <a:ln>
-            <a:noFill/>
-          </a:ln>
-          <a:effectLst/>
-        </p:spPr>
-        <p:style>
-          <a:lnRef idx="1">
-            <a:schemeClr val="accent1"/>
-          </a:lnRef>
-          <a:fillRef idx="3">
-            <a:schemeClr val="accent1"/>
-          </a:fillRef>
-          <a:effectRef idx="2">
-            <a:schemeClr val="accent1"/>
-          </a:effectRef>
-          <a:fontRef idx="minor">
-            <a:schemeClr val="lt1"/>
-          </a:fontRef>
-        </p:style>
-        <p:txBody>
-          <a:bodyPr rtlCol="0" anchor="ctr"/>
-          <a:lstStyle/>
-          <a:p>
-            <a:pPr algn="ctr"/>
-          </a:p>
-        </p:txBody>
-      </p:sp>
-      <p:sp>
-        <p:nvSpPr>
-          <p:cNvPr id="15" name="Rectangle 14"/>
-          <p:cNvSpPr/>
-          <p:nvPr/>
-        </p:nvSpPr>
-        <p:spPr>
-          <a:xfrm>
-            <a:off x="0" y="2743200"/>
-            <a:ext cx="9144000" cy="9144"/>
-          </a:xfrm>
-          <a:prstGeom prst="rect">
-            <a:avLst/>
-          </a:prstGeom>
-          <a:solidFill>
-            <a:srgbClr val="22E6FF">
-              <a:alpha val="6000"/>
-            </a:srgbClr>
-          </a:solidFill>
-          <a:ln>
-            <a:noFill/>
-          </a:ln>
-          <a:effectLst/>
-        </p:spPr>
-        <p:style>
-          <a:lnRef idx="1">
-            <a:schemeClr val="accent1"/>
-          </a:lnRef>
-          <a:fillRef idx="3">
-            <a:schemeClr val="accent1"/>
-          </a:fillRef>
-          <a:effectRef idx="2">
-            <a:schemeClr val="accent1"/>
-          </a:effectRef>
-          <a:fontRef idx="minor">
-            <a:schemeClr val="lt1"/>
-          </a:fontRef>
-        </p:style>
-        <p:txBody>
-          <a:bodyPr rtlCol="0" anchor="ctr"/>
-          <a:lstStyle/>
-          <a:p>
-            <a:pPr algn="ctr"/>
-          </a:p>
-        </p:txBody>
-      </p:sp>
-      <p:sp>
-        <p:nvSpPr>
-          <p:cNvPr id="16" name="Rectangle 15"/>
-          <p:cNvSpPr/>
-          <p:nvPr/>
-        </p:nvSpPr>
-        <p:spPr>
-          <a:xfrm>
-            <a:off x="0" y="3657600"/>
-            <a:ext cx="9144000" cy="9144"/>
-          </a:xfrm>
-          <a:prstGeom prst="rect">
-            <a:avLst/>
-          </a:prstGeom>
-          <a:solidFill>
-            <a:srgbClr val="22E6FF">
-              <a:alpha val="6000"/>
-            </a:srgbClr>
-          </a:solidFill>
-          <a:ln>
-            <a:noFill/>
-          </a:ln>
-          <a:effectLst/>
-        </p:spPr>
-        <p:style>
-          <a:lnRef idx="1">
-            <a:schemeClr val="accent1"/>
-          </a:lnRef>
-          <a:fillRef idx="3">
-            <a:schemeClr val="accent1"/>
-          </a:fillRef>
-          <a:effectRef idx="2">
-            <a:schemeClr val="accent1"/>
-          </a:effectRef>
-          <a:fontRef idx="minor">
-            <a:schemeClr val="lt1"/>
-          </a:fontRef>
-        </p:style>
-        <p:txBody>
-          <a:bodyPr rtlCol="0" anchor="ctr"/>
-          <a:lstStyle/>
-          <a:p>
-            <a:pPr algn="ctr"/>
-          </a:p>
-        </p:txBody>
-      </p:sp>
-      <p:sp>
-        <p:nvSpPr>
-          <p:cNvPr id="17" name="Rectangle 16"/>
-          <p:cNvSpPr/>
-          <p:nvPr/>
-        </p:nvSpPr>
-        <p:spPr>
-          <a:xfrm>
-            <a:off x="0" y="4572000"/>
-            <a:ext cx="9144000" cy="9144"/>
-          </a:xfrm>
-          <a:prstGeom prst="rect">
-            <a:avLst/>
-          </a:prstGeom>
-          <a:solidFill>
-            <a:srgbClr val="22E6FF">
-              <a:alpha val="6000"/>
-            </a:srgbClr>
-          </a:solidFill>
-          <a:ln>
-            <a:noFill/>
-          </a:ln>
-          <a:effectLst/>
-        </p:spPr>
-        <p:style>
-          <a:lnRef idx="1">
-            <a:schemeClr val="accent1"/>
-          </a:lnRef>
-          <a:fillRef idx="3">
-            <a:schemeClr val="accent1"/>
-          </a:fillRef>
-          <a:effectRef idx="2">
-            <a:schemeClr val="accent1"/>
-          </a:effectRef>
-          <a:fontRef idx="minor">
-            <a:schemeClr val="lt1"/>
-          </a:fontRef>
-        </p:style>
-        <p:txBody>
-          <a:bodyPr rtlCol="0" anchor="ctr"/>
-          <a:lstStyle/>
-          <a:p>
-            <a:pPr algn="ctr"/>
-          </a:p>
-        </p:txBody>
-      </p:sp>
-      <p:sp>
-        <p:nvSpPr>
-          <p:cNvPr id="18" name="TextBox 17"/>
-          <p:cNvSpPr txBox="1"/>
-          <p:nvPr/>
-        </p:nvSpPr>
-        <p:spPr>
-          <a:xfrm>
-            <a:off x="457200" y="274320"/>
-            <a:ext cx="5486400" cy="274320"/>
-          </a:xfrm>
-          <a:prstGeom prst="rect">
-            <a:avLst/>
-          </a:prstGeom>
-          <a:noFill/>
-        </p:spPr>
-        <p:txBody>
-          <a:bodyPr wrap="square" anchor="t" lIns="0" rIns="0" tIns="0" bIns="0">
-            <a:spAutoFit/>
-          </a:bodyPr>
-          <a:lstStyle/>
-          <a:p>
-            <a:pPr algn="l"/>
-            <a:r>
-              <a:rPr sz="1300" b="1">
-                <a:solidFill>
-                  <a:srgbClr val="E6F7FF"/>
-                </a:solidFill>
-                <a:latin typeface="Orbitron"/>
-              </a:rPr>
-              <a:t>RIO DO SUL </a:t>
-            </a:r>
-            <a:r>
-              <a:rPr sz="1300" b="1">
-                <a:solidFill>
-                  <a:srgbClr val="22E6FF"/>
-                </a:solidFill>
-                <a:latin typeface="Orbitron"/>
-              </a:rPr>
-              <a:t>MAIS TEC</a:t>
-            </a:r>
-          </a:p>
-        </p:txBody>
-      </p:sp>
-      <p:sp>
-        <p:nvSpPr>
-          <p:cNvPr id="19" name="TextBox 18"/>
-          <p:cNvSpPr txBox="1"/>
-          <p:nvPr/>
-        </p:nvSpPr>
-        <p:spPr>
-          <a:xfrm>
-            <a:off x="5486400" y="292608"/>
-            <a:ext cx="3200400" cy="274320"/>
-          </a:xfrm>
-          <a:prstGeom prst="rect">
-            <a:avLst/>
-          </a:prstGeom>
-          <a:noFill/>
-        </p:spPr>
-        <p:txBody>
-          <a:bodyPr wrap="square" anchor="t" lIns="0" rIns="0" tIns="0" bIns="0">
-            <a:spAutoFit/>
-          </a:bodyPr>
-          <a:lstStyle/>
-          <a:p>
-            <a:pPr algn="r"/>
-            <a:r>
-              <a:rPr sz="1000" b="0">
-                <a:solidFill>
-                  <a:srgbClr val="FF2BD6"/>
-                </a:solidFill>
-                <a:latin typeface="Share Tech Mono"/>
-              </a:rPr>
-              <a:t>HACKATHON DO FUTURO</a:t>
-            </a:r>
-          </a:p>
-        </p:txBody>
-      </p:sp>
-      <p:sp>
-        <p:nvSpPr>
-          <p:cNvPr id="20" name="Rectangle 19"/>
-          <p:cNvSpPr/>
-          <p:nvPr/>
-        </p:nvSpPr>
-        <p:spPr>
-          <a:xfrm>
-            <a:off x="457200" y="621792"/>
-            <a:ext cx="8229600" cy="18288"/>
-          </a:xfrm>
-          <a:prstGeom prst="rect">
-            <a:avLst/>
-          </a:prstGeom>
-          <a:solidFill>
-            <a:srgbClr val="22E6FF">
-              <a:alpha val="70000"/>
-            </a:srgbClr>
-          </a:solidFill>
-          <a:ln>
-            <a:noFill/>
-          </a:ln>
-          <a:effectLst/>
-        </p:spPr>
-        <p:style>
-          <a:lnRef idx="1">
-            <a:schemeClr val="accent1"/>
-          </a:lnRef>
-          <a:fillRef idx="3">
-            <a:schemeClr val="accent1"/>
-          </a:fillRef>
-          <a:effectRef idx="2">
-            <a:schemeClr val="accent1"/>
-          </a:effectRef>
-          <a:fontRef idx="minor">
-            <a:schemeClr val="lt1"/>
-          </a:fontRef>
-        </p:style>
-        <p:txBody>
-          <a:bodyPr rtlCol="0" anchor="ctr"/>
-          <a:lstStyle/>
-          <a:p>
-            <a:pPr algn="ctr"/>
-          </a:p>
-        </p:txBody>
-      </p:sp>
-      <p:sp>
-        <p:nvSpPr>
-          <p:cNvPr id="21" name="TextBox 20"/>
-          <p:cNvSpPr txBox="1"/>
-          <p:nvPr/>
-        </p:nvSpPr>
-        <p:spPr>
-          <a:xfrm>
-            <a:off x="457200" y="914400"/>
-            <a:ext cx="8229600" cy="914400"/>
-          </a:xfrm>
-          <a:prstGeom prst="rect">
-            <a:avLst/>
-          </a:prstGeom>
-          <a:noFill/>
-        </p:spPr>
-        <p:txBody>
-          <a:bodyPr wrap="square" anchor="t" lIns="0" rIns="0" tIns="0" bIns="0">
-            <a:spAutoFit/>
-          </a:bodyPr>
-          <a:lstStyle/>
-          <a:p>
-            <a:pPr algn="l"/>
-            <a:r>
-              <a:rPr sz="5400" b="1">
-                <a:solidFill>
-                  <a:srgbClr val="E6F7FF"/>
-                </a:solidFill>
-                <a:latin typeface="Orbitron"/>
-              </a:rPr>
-              <a:t>AUTOTEC</a:t>
-            </a:r>
-          </a:p>
-        </p:txBody>
-      </p:sp>
-      <p:sp>
-        <p:nvSpPr>
-          <p:cNvPr id="22" name="TextBox 21"/>
-          <p:cNvSpPr txBox="1"/>
-          <p:nvPr/>
-        </p:nvSpPr>
-        <p:spPr>
-          <a:xfrm>
-            <a:off x="457200" y="1783080"/>
-            <a:ext cx="8229600" cy="365760"/>
-          </a:xfrm>
-          <a:prstGeom prst="rect">
-            <a:avLst/>
-          </a:prstGeom>
-          <a:noFill/>
-        </p:spPr>
-        <p:txBody>
-          <a:bodyPr wrap="square" anchor="t" lIns="0" rIns="0" tIns="0" bIns="0">
-            <a:spAutoFit/>
-          </a:bodyPr>
-          <a:lstStyle/>
-          <a:p>
-            <a:pPr algn="l"/>
-            <a:r>
-              <a:rPr sz="1800" b="0">
-                <a:solidFill>
-                  <a:srgbClr val="E6F7FF"/>
-                </a:solidFill>
-                <a:latin typeface="Share Tech Mono"/>
-              </a:rPr>
-              <a:t>Rio do Sul </a:t>
-            </a:r>
-            <a:r>
-              <a:rPr sz="1800" b="1">
-                <a:solidFill>
-                  <a:srgbClr val="22E6FF"/>
-                </a:solidFill>
-                <a:latin typeface="Share Tech Mono"/>
-              </a:rPr>
-              <a:t>Mais Tec</a:t>
-            </a:r>
-            <a:r>
-              <a:rPr sz="1800" b="0">
-                <a:solidFill>
-                  <a:srgbClr val="8FA3C7"/>
-                </a:solidFill>
-                <a:latin typeface="Share Tech Mono"/>
-              </a:rPr>
-              <a:t>  ·  Hackathon do Futuro</a:t>
-            </a:r>
-          </a:p>
-        </p:txBody>
-      </p:sp>
-      <p:sp>
-        <p:nvSpPr>
-          <p:cNvPr id="23" name="Rounded Rectangle 22"/>
-          <p:cNvSpPr/>
-          <p:nvPr/>
-        </p:nvSpPr>
-        <p:spPr>
-          <a:xfrm>
-            <a:off x="457200" y="2331720"/>
-            <a:ext cx="8229600" cy="566928"/>
-          </a:xfrm>
-          <a:prstGeom prst="roundRect">
-            <a:avLst>
-              <a:gd name="adj" fmla="val 18000"/>
-            </a:avLst>
-          </a:prstGeom>
-          <a:solidFill>
-            <a:srgbClr val="100A24">
-              <a:alpha val="85000"/>
-            </a:srgbClr>
-          </a:solidFill>
-          <a:ln w="15875">
-            <a:solidFill>
-              <a:srgbClr val="22E6FF"/>
-            </a:solidFill>
-          </a:ln>
-          <a:effectLst/>
-        </p:spPr>
-        <p:style>
-          <a:lnRef idx="1">
-            <a:schemeClr val="accent1"/>
-          </a:lnRef>
-          <a:fillRef idx="3">
-            <a:schemeClr val="accent1"/>
-          </a:fillRef>
-          <a:effectRef idx="2">
-            <a:schemeClr val="accent1"/>
-          </a:effectRef>
-          <a:fontRef idx="minor">
-            <a:schemeClr val="lt1"/>
-          </a:fontRef>
-        </p:style>
-        <p:txBody>
-          <a:bodyPr rtlCol="0" anchor="ctr"/>
-          <a:lstStyle/>
-          <a:p>
-            <a:pPr algn="ctr"/>
-          </a:p>
-        </p:txBody>
-      </p:sp>
-      <p:sp>
-        <p:nvSpPr>
-          <p:cNvPr id="24" name="TextBox 23"/>
-          <p:cNvSpPr txBox="1"/>
-          <p:nvPr/>
-        </p:nvSpPr>
-        <p:spPr>
-          <a:xfrm>
-            <a:off x="685800" y="2331720"/>
-            <a:ext cx="548640" cy="566928"/>
-          </a:xfrm>
-          <a:prstGeom prst="rect">
-            <a:avLst/>
-          </a:prstGeom>
-          <a:noFill/>
-        </p:spPr>
-        <p:txBody>
-          <a:bodyPr wrap="square" anchor="ctr" lIns="0" rIns="0" tIns="0" bIns="0">
-            <a:spAutoFit/>
-          </a:bodyPr>
-          <a:lstStyle/>
-          <a:p>
-            <a:pPr algn="l"/>
-            <a:r>
-              <a:rPr sz="1600" b="1">
-                <a:solidFill>
-                  <a:srgbClr val="FF2BD6"/>
-                </a:solidFill>
-                <a:latin typeface="Orbitron"/>
-              </a:rPr>
-              <a:t>01</a:t>
-            </a:r>
-          </a:p>
-        </p:txBody>
-      </p:sp>
-      <p:sp>
-        <p:nvSpPr>
-          <p:cNvPr id="25" name="TextBox 24"/>
-          <p:cNvSpPr txBox="1"/>
-          <p:nvPr/>
-        </p:nvSpPr>
-        <p:spPr>
-          <a:xfrm>
-            <a:off x="1280160" y="2377439"/>
-            <a:ext cx="7223760" cy="475488"/>
-          </a:xfrm>
-          <a:prstGeom prst="rect">
-            <a:avLst/>
-          </a:prstGeom>
-          <a:noFill/>
-        </p:spPr>
-        <p:txBody>
-          <a:bodyPr wrap="square" anchor="ctr" lIns="0" rIns="0" tIns="0" bIns="0">
-            <a:spAutoFit/>
-          </a:bodyPr>
-          <a:lstStyle/>
-          <a:p>
-            <a:pPr algn="l"/>
-            <a:r>
-              <a:rPr sz="1600" b="0">
-                <a:solidFill>
-                  <a:srgbClr val="E6F7FF"/>
-                </a:solidFill>
-                <a:latin typeface="Share Tech Mono"/>
-              </a:rPr>
-              <a:t>Segurança para quem atravessa perto das escolas de Rio do Sul.</a:t>
-            </a:r>
-          </a:p>
-        </p:txBody>
-      </p:sp>
-      <p:sp>
-        <p:nvSpPr>
-          <p:cNvPr id="26" name="Rounded Rectangle 25"/>
-          <p:cNvSpPr/>
-          <p:nvPr/>
-        </p:nvSpPr>
-        <p:spPr>
-          <a:xfrm>
-            <a:off x="457200" y="3026663"/>
-            <a:ext cx="8229600" cy="566928"/>
-          </a:xfrm>
-          <a:prstGeom prst="roundRect">
-            <a:avLst>
-              <a:gd name="adj" fmla="val 18000"/>
-            </a:avLst>
-          </a:prstGeom>
-          <a:solidFill>
-            <a:srgbClr val="100A24">
-              <a:alpha val="85000"/>
-            </a:srgbClr>
-          </a:solidFill>
-          <a:ln w="15875">
-            <a:solidFill>
-              <a:srgbClr val="22E6FF"/>
-            </a:solidFill>
-          </a:ln>
-          <a:effectLst/>
-        </p:spPr>
-        <p:style>
-          <a:lnRef idx="1">
-            <a:schemeClr val="accent1"/>
-          </a:lnRef>
-          <a:fillRef idx="3">
-            <a:schemeClr val="accent1"/>
-          </a:fillRef>
-          <a:effectRef idx="2">
-            <a:schemeClr val="accent1"/>
-          </a:effectRef>
-          <a:fontRef idx="minor">
-            <a:schemeClr val="lt1"/>
-          </a:fontRef>
-        </p:style>
-        <p:txBody>
-          <a:bodyPr rtlCol="0" anchor="ctr"/>
-          <a:lstStyle/>
-          <a:p>
-            <a:pPr algn="ctr"/>
-          </a:p>
-        </p:txBody>
-      </p:sp>
-      <p:sp>
-        <p:nvSpPr>
-          <p:cNvPr id="27" name="TextBox 26"/>
-          <p:cNvSpPr txBox="1"/>
-          <p:nvPr/>
-        </p:nvSpPr>
-        <p:spPr>
-          <a:xfrm>
-            <a:off x="685800" y="3026663"/>
-            <a:ext cx="548640" cy="566928"/>
-          </a:xfrm>
-          <a:prstGeom prst="rect">
-            <a:avLst/>
-          </a:prstGeom>
-          <a:noFill/>
-        </p:spPr>
-        <p:txBody>
-          <a:bodyPr wrap="square" anchor="ctr" lIns="0" rIns="0" tIns="0" bIns="0">
-            <a:spAutoFit/>
-          </a:bodyPr>
-          <a:lstStyle/>
-          <a:p>
-            <a:pPr algn="l"/>
-            <a:r>
-              <a:rPr sz="1600" b="1">
-                <a:solidFill>
-                  <a:srgbClr val="FF2BD6"/>
-                </a:solidFill>
-                <a:latin typeface="Orbitron"/>
-              </a:rPr>
-              <a:t>02</a:t>
-            </a:r>
-          </a:p>
-        </p:txBody>
-      </p:sp>
-      <p:sp>
-        <p:nvSpPr>
-          <p:cNvPr id="28" name="TextBox 27"/>
-          <p:cNvSpPr txBox="1"/>
-          <p:nvPr/>
-        </p:nvSpPr>
-        <p:spPr>
-          <a:xfrm>
-            <a:off x="1280160" y="3072383"/>
-            <a:ext cx="7223760" cy="475488"/>
-          </a:xfrm>
-          <a:prstGeom prst="rect">
-            <a:avLst/>
-          </a:prstGeom>
-          <a:noFill/>
-        </p:spPr>
-        <p:txBody>
-          <a:bodyPr wrap="square" anchor="ctr" lIns="0" rIns="0" tIns="0" bIns="0">
-            <a:spAutoFit/>
-          </a:bodyPr>
-          <a:lstStyle/>
-          <a:p>
-            <a:pPr algn="l"/>
-            <a:r>
-              <a:rPr sz="1600" b="0">
-                <a:solidFill>
-                  <a:srgbClr val="E6F7FF"/>
-                </a:solidFill>
-                <a:latin typeface="Share Tech Mono"/>
-              </a:rPr>
-              <a:t>Uma solução para scooters e bicicletas elétricas nas ciclofaixas.</a:t>
-            </a:r>
-          </a:p>
-        </p:txBody>
-      </p:sp>
-      <p:sp>
-        <p:nvSpPr>
-          <p:cNvPr id="29" name="Rounded Rectangle 28"/>
-          <p:cNvSpPr/>
-          <p:nvPr/>
-        </p:nvSpPr>
-        <p:spPr>
-          <a:xfrm>
-            <a:off x="457200" y="3721608"/>
-            <a:ext cx="8229600" cy="566928"/>
-          </a:xfrm>
-          <a:prstGeom prst="roundRect">
-            <a:avLst>
-              <a:gd name="adj" fmla="val 18000"/>
-            </a:avLst>
-          </a:prstGeom>
-          <a:solidFill>
-            <a:srgbClr val="100A24">
-              <a:alpha val="85000"/>
-            </a:srgbClr>
-          </a:solidFill>
-          <a:ln w="15875">
-            <a:solidFill>
-              <a:srgbClr val="22E6FF"/>
-            </a:solidFill>
-          </a:ln>
-          <a:effectLst/>
-        </p:spPr>
-        <p:style>
-          <a:lnRef idx="1">
-            <a:schemeClr val="accent1"/>
-          </a:lnRef>
-          <a:fillRef idx="3">
-            <a:schemeClr val="accent1"/>
-          </a:fillRef>
-          <a:effectRef idx="2">
-            <a:schemeClr val="accent1"/>
-          </a:effectRef>
-          <a:fontRef idx="minor">
-            <a:schemeClr val="lt1"/>
-          </a:fontRef>
-        </p:style>
-        <p:txBody>
-          <a:bodyPr rtlCol="0" anchor="ctr"/>
-          <a:lstStyle/>
-          <a:p>
-            <a:pPr algn="ctr"/>
-          </a:p>
-        </p:txBody>
-      </p:sp>
-      <p:sp>
-        <p:nvSpPr>
-          <p:cNvPr id="30" name="TextBox 29"/>
-          <p:cNvSpPr txBox="1"/>
-          <p:nvPr/>
-        </p:nvSpPr>
-        <p:spPr>
-          <a:xfrm>
-            <a:off x="685800" y="3721608"/>
-            <a:ext cx="548640" cy="566928"/>
-          </a:xfrm>
-          <a:prstGeom prst="rect">
-            <a:avLst/>
-          </a:prstGeom>
-          <a:noFill/>
-        </p:spPr>
-        <p:txBody>
-          <a:bodyPr wrap="square" anchor="ctr" lIns="0" rIns="0" tIns="0" bIns="0">
-            <a:spAutoFit/>
-          </a:bodyPr>
-          <a:lstStyle/>
-          <a:p>
-            <a:pPr algn="l"/>
-            <a:r>
-              <a:rPr sz="1600" b="1">
-                <a:solidFill>
-                  <a:srgbClr val="FF2BD6"/>
-                </a:solidFill>
-                <a:latin typeface="Orbitron"/>
-              </a:rPr>
-              <a:t>03</a:t>
-            </a:r>
-          </a:p>
-        </p:txBody>
-      </p:sp>
-      <p:sp>
-        <p:nvSpPr>
-          <p:cNvPr id="31" name="TextBox 30"/>
-          <p:cNvSpPr txBox="1"/>
-          <p:nvPr/>
-        </p:nvSpPr>
-        <p:spPr>
-          <a:xfrm>
-            <a:off x="1280160" y="3767328"/>
-            <a:ext cx="7223760" cy="475488"/>
-          </a:xfrm>
-          <a:prstGeom prst="rect">
-            <a:avLst/>
-          </a:prstGeom>
-          <a:noFill/>
-        </p:spPr>
-        <p:txBody>
-          <a:bodyPr wrap="square" anchor="ctr" lIns="0" rIns="0" tIns="0" bIns="0">
-            <a:spAutoFit/>
-          </a:bodyPr>
-          <a:lstStyle/>
-          <a:p>
-            <a:pPr algn="l"/>
-            <a:r>
-              <a:rPr sz="1600" b="0">
-                <a:solidFill>
-                  <a:srgbClr val="E6F7FF"/>
-                </a:solidFill>
-                <a:latin typeface="Share Tech Mono"/>
-              </a:rPr>
-              <a:t>Nosso desafio: como podemos melhorar nossa cidade?</a:t>
-            </a:r>
-          </a:p>
-        </p:txBody>
-      </p:sp>
-      <p:sp>
-        <p:nvSpPr>
-          <p:cNvPr id="32" name="TextBox 31"/>
-          <p:cNvSpPr txBox="1"/>
-          <p:nvPr/>
-        </p:nvSpPr>
-        <p:spPr>
-          <a:xfrm>
-            <a:off x="457200" y="4754880"/>
-            <a:ext cx="6400800" cy="228600"/>
-          </a:xfrm>
-          <a:prstGeom prst="rect">
-            <a:avLst/>
-          </a:prstGeom>
-          <a:noFill/>
-        </p:spPr>
-        <p:txBody>
-          <a:bodyPr wrap="square" anchor="t" lIns="0" rIns="0" tIns="0" bIns="0">
-            <a:spAutoFit/>
-          </a:bodyPr>
-          <a:lstStyle/>
-          <a:p>
-            <a:pPr algn="l"/>
-            <a:r>
-              <a:rPr sz="1000" b="1">
-                <a:solidFill>
-                  <a:srgbClr val="22E6FF"/>
-                </a:solidFill>
-                <a:latin typeface="Orbitron"/>
-              </a:rPr>
-              <a:t>RIO DO SUL MAIS TEC</a:t>
-            </a:r>
-            <a:r>
-              <a:rPr sz="1000" b="0">
-                <a:solidFill>
-                  <a:srgbClr val="8FA3C7"/>
-                </a:solidFill>
-                <a:latin typeface="Share Tech Mono"/>
-              </a:rPr>
-              <a:t>  ·  </a:t>
-            </a:r>
-            <a:r>
-              <a:rPr sz="1000" b="1">
-                <a:solidFill>
-                  <a:srgbClr val="E6F7FF"/>
-                </a:solidFill>
-                <a:latin typeface="Orbitron"/>
-              </a:rPr>
-              <a:t>SENAI</a:t>
-            </a:r>
-            <a:r>
-              <a:rPr sz="1000" b="0">
-                <a:solidFill>
-                  <a:srgbClr val="8FA3C7"/>
-                </a:solidFill>
-                <a:latin typeface="Share Tech Mono"/>
-              </a:rPr>
-              <a:t>  ·  </a:t>
-            </a:r>
-            <a:r>
-              <a:rPr sz="1000" b="1">
-                <a:solidFill>
-                  <a:srgbClr val="FF2BD6"/>
-                </a:solidFill>
-                <a:latin typeface="Orbitron"/>
-              </a:rPr>
-              <a:t>&lt;LAB365&gt;</a:t>
-            </a:r>
-          </a:p>
-        </p:txBody>
-      </p:sp>
-      <p:sp>
-        <p:nvSpPr>
-          <p:cNvPr id="33" name="TextBox 32"/>
-          <p:cNvSpPr txBox="1"/>
-          <p:nvPr/>
-        </p:nvSpPr>
-        <p:spPr>
-          <a:xfrm>
-            <a:off x="7772400" y="4754880"/>
-            <a:ext cx="914400" cy="228600"/>
-          </a:xfrm>
-          <a:prstGeom prst="rect">
-            <a:avLst/>
-          </a:prstGeom>
-          <a:noFill/>
-        </p:spPr>
-        <p:txBody>
-          <a:bodyPr wrap="square" anchor="t" lIns="0" rIns="0" tIns="0" bIns="0">
-            <a:spAutoFit/>
-          </a:bodyPr>
-          <a:lstStyle/>
-          <a:p>
-            <a:pPr algn="r"/>
-            <a:r>
-              <a:rPr sz="1000" b="0">
-                <a:solidFill>
-                  <a:srgbClr val="8FA3C7"/>
-                </a:solidFill>
-                <a:latin typeface="Share Tech Mono"/>
-              </a:rPr>
-              <a:t>1/5</a:t>
-            </a:r>
-          </a:p>
-        </p:txBody>
-      </p:sp>
+      <p:pic>
+        <p:nvPicPr>
+          <p:cNvPr id="2" name="Picture 1" descr="capa-hackathon-2026.jpg"/>
+          <p:cNvPicPr>
+            <a:picLocks noChangeAspect="1"/>
+          </p:cNvPicPr>
+          <p:nvPr/>
+        </p:nvPicPr>
+        <p:blipFill>
+          <a:blip r:embed="rId2"/>
+          <a:stretch>
+            <a:fillRect/>
+          </a:stretch>
+        </p:blipFill>
+        <p:spPr>
+          <a:xfrm>
+            <a:off x="0" y="0"/>
+            <a:ext cx="9144000" cy="5143500"/>
+          </a:xfrm>
+          <a:prstGeom prst="rect">
+            <a:avLst/>
+          </a:prstGeom>
+        </p:spPr>
+      </p:pic>
     </p:spTree>
   </p:cSld>
   <p:clrMapOvr>
@@ -2975,7 +1577,7 @@
                 </a:solidFill>
                 <a:latin typeface="Share Tech Mono"/>
               </a:rPr>
-              <a:t>01 // O PROBLEMA</a:t>
+              <a:t>HACKATHON DO FUTURO</a:t>
             </a:r>
           </a:p>
         </p:txBody>
@@ -3034,8 +1636,8 @@
         </p:nvSpPr>
         <p:spPr>
           <a:xfrm>
-            <a:off x="457200" y="822960"/>
-            <a:ext cx="8229600" cy="640080"/>
+            <a:off x="457200" y="914400"/>
+            <a:ext cx="8229600" cy="914400"/>
           </a:xfrm>
           <a:prstGeom prst="rect">
             <a:avLst/>
@@ -3050,27 +1652,80 @@
           <a:p>
             <a:pPr algn="l"/>
             <a:r>
-              <a:rPr sz="2600" b="1">
+              <a:rPr sz="5400" b="1">
                 <a:solidFill>
                   <a:srgbClr val="E6F7FF"/>
                 </a:solidFill>
                 <a:latin typeface="Orbitron"/>
               </a:rPr>
-              <a:t>Scooters rápidas perto das escolas</a:t>
-            </a:r>
-          </a:p>
-        </p:txBody>
-      </p:sp>
-      <p:sp>
-        <p:nvSpPr>
-          <p:cNvPr id="22" name="Rounded Rectangle 21"/>
-          <p:cNvSpPr/>
-          <p:nvPr/>
-        </p:nvSpPr>
-        <p:spPr>
-          <a:xfrm>
-            <a:off x="457200" y="1600200"/>
-            <a:ext cx="8229600" cy="804672"/>
+              <a:t>AUTOTEC</a:t>
+            </a:r>
+          </a:p>
+        </p:txBody>
+      </p:sp>
+      <p:sp>
+        <p:nvSpPr>
+          <p:cNvPr id="22" name="TextBox 21"/>
+          <p:cNvSpPr txBox="1"/>
+          <p:nvPr/>
+        </p:nvSpPr>
+        <p:spPr>
+          <a:xfrm>
+            <a:off x="457200" y="1783080"/>
+            <a:ext cx="8229600" cy="365760"/>
+          </a:xfrm>
+          <a:prstGeom prst="rect">
+            <a:avLst/>
+          </a:prstGeom>
+          <a:noFill/>
+        </p:spPr>
+        <p:txBody>
+          <a:bodyPr wrap="square" anchor="t" lIns="0" rIns="0" tIns="0" bIns="0">
+            <a:spAutoFit/>
+          </a:bodyPr>
+          <a:lstStyle/>
+          <a:p>
+            <a:pPr algn="l"/>
+            <a:r>
+              <a:rPr sz="1800" b="0">
+                <a:solidFill>
+                  <a:srgbClr val="E6F7FF"/>
+                </a:solidFill>
+                <a:latin typeface="Share Tech Mono"/>
+              </a:rPr>
+              <a:t>Rio do Sul </a:t>
+            </a:r>
+            <a:r>
+              <a:rPr sz="1800" b="1">
+                <a:solidFill>
+                  <a:srgbClr val="22E6FF"/>
+                </a:solidFill>
+                <a:latin typeface="Share Tech Mono"/>
+              </a:rPr>
+              <a:t>Mais Tec</a:t>
+            </a:r>
+            <a:r>
+              <a:rPr sz="1800" b="0">
+                <a:solidFill>
+                  <a:srgbClr val="8FA3C7"/>
+                </a:solidFill>
+                <a:latin typeface="Share Tech Mono"/>
+              </a:rPr>
+              <a:t>  ·  Hackathon do Futuro</a:t>
+            </a:r>
+          </a:p>
+        </p:txBody>
+      </p:sp>
+      <p:sp>
+        <p:nvSpPr>
+          <p:cNvPr id="23" name="Rounded Rectangle 22"/>
+          <p:cNvSpPr/>
+          <p:nvPr/>
+        </p:nvSpPr>
+        <p:spPr>
+          <a:xfrm>
+            <a:off x="457200" y="2331720"/>
+            <a:ext cx="8229600" cy="566928"/>
           </a:xfrm>
           <a:prstGeom prst="roundRect">
             <a:avLst>
@@ -3113,14 +1768,14 @@
       </p:sp>
       <p:sp>
         <p:nvSpPr>
-          <p:cNvPr id="23" name="TextBox 22"/>
+          <p:cNvPr id="24" name="TextBox 23"/>
           <p:cNvSpPr txBox="1"/>
           <p:nvPr/>
         </p:nvSpPr>
         <p:spPr>
           <a:xfrm>
-            <a:off x="685800" y="1600200"/>
-            <a:ext cx="548640" cy="804672"/>
+            <a:off x="685800" y="2331720"/>
+            <a:ext cx="548640" cy="566928"/>
           </a:xfrm>
           <a:prstGeom prst="rect">
             <a:avLst/>
@@ -3148,14 +1803,14 @@
       </p:sp>
       <p:sp>
         <p:nvSpPr>
-          <p:cNvPr id="24" name="TextBox 23"/>
+          <p:cNvPr id="25" name="TextBox 24"/>
           <p:cNvSpPr txBox="1"/>
           <p:nvPr/>
         </p:nvSpPr>
         <p:spPr>
           <a:xfrm>
-            <a:off x="1280160" y="1645920"/>
-            <a:ext cx="7223760" cy="713232"/>
+            <a:off x="1280160" y="2377439"/>
+            <a:ext cx="7223760" cy="475488"/>
           </a:xfrm>
           <a:prstGeom prst="rect">
             <a:avLst/>
@@ -3170,27 +1825,27 @@
           <a:p>
             <a:pPr algn="l"/>
             <a:r>
-              <a:rPr sz="1800" b="0">
+              <a:rPr sz="1600" b="0">
                 <a:solidFill>
                   <a:srgbClr val="E6F7FF"/>
                 </a:solidFill>
                 <a:latin typeface="Share Tech Mono"/>
               </a:rPr>
-              <a:t>Muitos autopropelidos circulam em Rio do Sul, inclusive perto das escolas.</a:t>
-            </a:r>
-          </a:p>
-        </p:txBody>
-      </p:sp>
-      <p:sp>
-        <p:nvSpPr>
-          <p:cNvPr id="25" name="Rounded Rectangle 24"/>
-          <p:cNvSpPr/>
-          <p:nvPr/>
-        </p:nvSpPr>
-        <p:spPr>
-          <a:xfrm>
-            <a:off x="457200" y="2569464"/>
-            <a:ext cx="8229600" cy="804672"/>
+              <a:t>Segurança para quem atravessa perto das escolas de Rio do Sul.</a:t>
+            </a:r>
+          </a:p>
+        </p:txBody>
+      </p:sp>
+      <p:sp>
+        <p:nvSpPr>
+          <p:cNvPr id="26" name="Rounded Rectangle 25"/>
+          <p:cNvSpPr/>
+          <p:nvPr/>
+        </p:nvSpPr>
+        <p:spPr>
+          <a:xfrm>
+            <a:off x="457200" y="3026663"/>
+            <a:ext cx="8229600" cy="566928"/>
           </a:xfrm>
           <a:prstGeom prst="roundRect">
             <a:avLst>
@@ -3233,14 +1888,14 @@
       </p:sp>
       <p:sp>
         <p:nvSpPr>
-          <p:cNvPr id="26" name="TextBox 25"/>
+          <p:cNvPr id="27" name="TextBox 26"/>
           <p:cNvSpPr txBox="1"/>
           <p:nvPr/>
         </p:nvSpPr>
         <p:spPr>
           <a:xfrm>
-            <a:off x="685800" y="2569464"/>
-            <a:ext cx="548640" cy="804672"/>
+            <a:off x="685800" y="3026663"/>
+            <a:ext cx="548640" cy="566928"/>
           </a:xfrm>
           <a:prstGeom prst="rect">
             <a:avLst/>
@@ -3268,14 +1923,14 @@
       </p:sp>
       <p:sp>
         <p:nvSpPr>
-          <p:cNvPr id="27" name="TextBox 26"/>
+          <p:cNvPr id="28" name="TextBox 27"/>
           <p:cNvSpPr txBox="1"/>
           <p:nvPr/>
         </p:nvSpPr>
         <p:spPr>
           <a:xfrm>
-            <a:off x="1280160" y="2615184"/>
-            <a:ext cx="7223760" cy="713232"/>
+            <a:off x="1280160" y="3072383"/>
+            <a:ext cx="7223760" cy="475488"/>
           </a:xfrm>
           <a:prstGeom prst="rect">
             <a:avLst/>
@@ -3290,27 +1945,27 @@
           <a:p>
             <a:pPr algn="l"/>
             <a:r>
-              <a:rPr sz="1800" b="0">
+              <a:rPr sz="1600" b="0">
                 <a:solidFill>
                   <a:srgbClr val="E6F7FF"/>
                 </a:solidFill>
                 <a:latin typeface="Share Tech Mono"/>
               </a:rPr>
-              <a:t>Crianças, jovens, pedestres e ciclistas correm risco ao atravessar.</a:t>
-            </a:r>
-          </a:p>
-        </p:txBody>
-      </p:sp>
-      <p:sp>
-        <p:nvSpPr>
-          <p:cNvPr id="28" name="Rounded Rectangle 27"/>
-          <p:cNvSpPr/>
-          <p:nvPr/>
-        </p:nvSpPr>
-        <p:spPr>
-          <a:xfrm>
-            <a:off x="457200" y="3538728"/>
-            <a:ext cx="8229600" cy="804672"/>
+              <a:t>Uma solução para scooters e bicicletas elétricas nas ciclofaixas.</a:t>
+            </a:r>
+          </a:p>
+        </p:txBody>
+      </p:sp>
+      <p:sp>
+        <p:nvSpPr>
+          <p:cNvPr id="29" name="Rounded Rectangle 28"/>
+          <p:cNvSpPr/>
+          <p:nvPr/>
+        </p:nvSpPr>
+        <p:spPr>
+          <a:xfrm>
+            <a:off x="457200" y="3721608"/>
+            <a:ext cx="8229600" cy="566928"/>
           </a:xfrm>
           <a:prstGeom prst="roundRect">
             <a:avLst>
@@ -3324,7 +1979,7 @@
           </a:solidFill>
           <a:ln w="15875">
             <a:solidFill>
-              <a:srgbClr val="FF2BD6"/>
+              <a:srgbClr val="22E6FF"/>
             </a:solidFill>
           </a:ln>
           <a:effectLst/>
@@ -3353,14 +2008,14 @@
       </p:sp>
       <p:sp>
         <p:nvSpPr>
-          <p:cNvPr id="29" name="TextBox 28"/>
+          <p:cNvPr id="30" name="TextBox 29"/>
           <p:cNvSpPr txBox="1"/>
           <p:nvPr/>
         </p:nvSpPr>
         <p:spPr>
           <a:xfrm>
-            <a:off x="685800" y="3538728"/>
-            <a:ext cx="548640" cy="804672"/>
+            <a:off x="685800" y="3721608"/>
+            <a:ext cx="548640" cy="566928"/>
           </a:xfrm>
           <a:prstGeom prst="rect">
             <a:avLst/>
@@ -3388,14 +2043,14 @@
       </p:sp>
       <p:sp>
         <p:nvSpPr>
-          <p:cNvPr id="30" name="TextBox 29"/>
+          <p:cNvPr id="31" name="TextBox 30"/>
           <p:cNvSpPr txBox="1"/>
           <p:nvPr/>
         </p:nvSpPr>
         <p:spPr>
           <a:xfrm>
-            <a:off x="1280160" y="3584448"/>
-            <a:ext cx="7223760" cy="713232"/>
+            <a:off x="1280160" y="3767328"/>
+            <a:ext cx="7223760" cy="475488"/>
           </a:xfrm>
           <a:prstGeom prst="rect">
             <a:avLst/>
@@ -3410,27 +2065,27 @@
           <a:p>
             <a:pPr algn="l"/>
             <a:r>
-              <a:rPr sz="1800" b="0">
+              <a:rPr sz="1600" b="0">
                 <a:solidFill>
                   <a:srgbClr val="E6F7FF"/>
                 </a:solidFill>
                 <a:latin typeface="Share Tech Mono"/>
               </a:rPr>
-              <a:t>[X] de 9 alunos da nossa turma já viram isso acontecer.</a:t>
-            </a:r>
-          </a:p>
-        </p:txBody>
-      </p:sp>
-      <p:sp>
-        <p:nvSpPr>
-          <p:cNvPr id="31" name="TextBox 30"/>
+              <a:t>Nosso desafio: como podemos melhorar nossa cidade?</a:t>
+            </a:r>
+          </a:p>
+        </p:txBody>
+      </p:sp>
+      <p:sp>
+        <p:nvSpPr>
+          <p:cNvPr id="32" name="TextBox 31"/>
           <p:cNvSpPr txBox="1"/>
           <p:nvPr/>
         </p:nvSpPr>
         <p:spPr>
           <a:xfrm>
             <a:off x="457200" y="4754880"/>
-            <a:ext cx="6400800" cy="228600"/>
+            <a:ext cx="7315200" cy="228600"/>
           </a:xfrm>
           <a:prstGeom prst="rect">
             <a:avLst/>
@@ -3445,7 +2100,7 @@
           <a:p>
             <a:pPr algn="l"/>
             <a:r>
-              <a:rPr sz="1000" b="1">
+              <a:rPr sz="900" b="1">
                 <a:solidFill>
                   <a:srgbClr val="22E6FF"/>
                 </a:solidFill>
@@ -3454,7 +2109,7 @@
               <a:t>RIO DO SUL MAIS TEC</a:t>
             </a:r>
             <a:r>
-              <a:rPr sz="1000" b="0">
+              <a:rPr sz="900" b="0">
                 <a:solidFill>
                   <a:srgbClr val="8FA3C7"/>
                 </a:solidFill>
@@ -3463,16 +2118,52 @@
               <a:t>  ·  </a:t>
             </a:r>
             <a:r>
-              <a:rPr sz="1000" b="1">
+              <a:rPr sz="900" b="1">
                 <a:solidFill>
                   <a:srgbClr val="E6F7FF"/>
                 </a:solidFill>
                 <a:latin typeface="Orbitron"/>
               </a:rPr>
+              <a:t>GOVERNO DE RIO DO SUL</a:t>
+            </a:r>
+            <a:r>
+              <a:rPr sz="900" b="0">
+                <a:solidFill>
+                  <a:srgbClr val="8FA3C7"/>
+                </a:solidFill>
+                <a:latin typeface="Share Tech Mono"/>
+              </a:rPr>
+              <a:t>  ·  </a:t>
+            </a:r>
+            <a:r>
+              <a:rPr sz="900" b="1">
+                <a:solidFill>
+                  <a:srgbClr val="FF2BD6"/>
+                </a:solidFill>
+                <a:latin typeface="Orbitron"/>
+              </a:rPr>
+              <a:t>&lt;LAB365&gt;</a:t>
+            </a:r>
+            <a:r>
+              <a:rPr sz="900" b="0">
+                <a:solidFill>
+                  <a:srgbClr val="8FA3C7"/>
+                </a:solidFill>
+                <a:latin typeface="Share Tech Mono"/>
+              </a:rPr>
+              <a:t>  ·  </a:t>
+            </a:r>
+            <a:r>
+              <a:rPr sz="900" b="1">
+                <a:solidFill>
+                  <a:srgbClr val="E6F7FF"/>
+                </a:solidFill>
+                <a:latin typeface="Orbitron"/>
+              </a:rPr>
               <a:t>SENAI</a:t>
             </a:r>
             <a:r>
-              <a:rPr sz="1000" b="0">
+              <a:rPr sz="900" b="0">
                 <a:solidFill>
                   <a:srgbClr val="8FA3C7"/>
                 </a:solidFill>
@@ -3481,20 +2172,20 @@
               <a:t>  ·  </a:t>
             </a:r>
             <a:r>
-              <a:rPr sz="1000" b="1">
-                <a:solidFill>
-                  <a:srgbClr val="FF2BD6"/>
+              <a:rPr sz="900" b="1">
+                <a:solidFill>
+                  <a:srgbClr val="E6F7FF"/>
                 </a:solidFill>
                 <a:latin typeface="Orbitron"/>
               </a:rPr>
-              <a:t>&lt;LAB365&gt;</a:t>
-            </a:r>
-          </a:p>
-        </p:txBody>
-      </p:sp>
-      <p:sp>
-        <p:nvSpPr>
-          <p:cNvPr id="32" name="TextBox 31"/>
+              <a:t>SESI</a:t>
+            </a:r>
+          </a:p>
+        </p:txBody>
+      </p:sp>
+      <p:sp>
+        <p:nvSpPr>
+          <p:cNvPr id="33" name="TextBox 32"/>
           <p:cNvSpPr txBox="1"/>
           <p:nvPr/>
         </p:nvSpPr>
@@ -3522,7 +2213,7 @@
                 </a:solidFill>
                 <a:latin typeface="Share Tech Mono"/>
               </a:rPr>
-              <a:t>2/5</a:t>
+              <a:t>2/6</a:t>
             </a:r>
           </a:p>
         </p:txBody>
@@ -4363,7 +3054,7 @@
                 </a:solidFill>
                 <a:latin typeface="Share Tech Mono"/>
               </a:rPr>
-              <a:t>02 // A SOLUÇÃO</a:t>
+              <a:t>01 // O PROBLEMA</a:t>
             </a:r>
           </a:p>
         </p:txBody>
@@ -4444,7 +3135,7 @@
                 </a:solidFill>
                 <a:latin typeface="Orbitron"/>
               </a:rPr>
-              <a:t>Como a Autotec funciona</a:t>
+              <a:t>Scooters rápidas perto das escolas</a:t>
             </a:r>
           </a:p>
         </p:txBody>
@@ -4564,7 +3255,7 @@
                 </a:solidFill>
                 <a:latin typeface="Share Tech Mono"/>
               </a:rPr>
-              <a:t>A scooter tem GPS e conhece as zonas de risco da cidade.</a:t>
+              <a:t>Muitos autopropelidos circulam em Rio do Sul, inclusive perto das escolas.</a:t>
             </a:r>
           </a:p>
         </p:txBody>
@@ -4684,7 +3375,7 @@
                 </a:solidFill>
                 <a:latin typeface="Share Tech Mono"/>
               </a:rPr>
-              <a:t>Perto da escola, ela desacelera sozinha e para antes da faixa de pedestres.</a:t>
+              <a:t>Crianças, jovens, pedestres e ciclistas correm risco ao atravessar.</a:t>
             </a:r>
           </a:p>
         </p:txBody>
@@ -4712,7 +3403,7 @@
           </a:solidFill>
           <a:ln w="15875">
             <a:solidFill>
-              <a:srgbClr val="22E6FF"/>
+              <a:srgbClr val="FF2BD6"/>
             </a:solidFill>
           </a:ln>
           <a:effectLst/>
@@ -4804,7 +3495,7 @@
                 </a:solidFill>
                 <a:latin typeface="Share Tech Mono"/>
               </a:rPr>
-              <a:t>Quem estava no limite de velocidade segue viagem normalmente.</a:t>
+              <a:t>[X] de 9 alunos da nossa turma já viram isso acontecer.</a:t>
             </a:r>
           </a:p>
         </p:txBody>
@@ -4818,7 +3509,7 @@
         <p:spPr>
           <a:xfrm>
             <a:off x="457200" y="4754880"/>
-            <a:ext cx="6400800" cy="228600"/>
+            <a:ext cx="7315200" cy="228600"/>
           </a:xfrm>
           <a:prstGeom prst="rect">
             <a:avLst/>
@@ -4833,7 +3524,7 @@
           <a:p>
             <a:pPr algn="l"/>
             <a:r>
-              <a:rPr sz="1000" b="1">
+              <a:rPr sz="900" b="1">
                 <a:solidFill>
                   <a:srgbClr val="22E6FF"/>
                 </a:solidFill>
@@ -4842,7 +3533,7 @@
               <a:t>RIO DO SUL MAIS TEC</a:t>
             </a:r>
             <a:r>
-              <a:rPr sz="1000" b="0">
+              <a:rPr sz="900" b="0">
                 <a:solidFill>
                   <a:srgbClr val="8FA3C7"/>
                 </a:solidFill>
@@ -4851,16 +3542,52 @@
               <a:t>  ·  </a:t>
             </a:r>
             <a:r>
-              <a:rPr sz="1000" b="1">
+              <a:rPr sz="900" b="1">
                 <a:solidFill>
                   <a:srgbClr val="E6F7FF"/>
                 </a:solidFill>
                 <a:latin typeface="Orbitron"/>
               </a:rPr>
+              <a:t>GOVERNO DE RIO DO SUL</a:t>
+            </a:r>
+            <a:r>
+              <a:rPr sz="900" b="0">
+                <a:solidFill>
+                  <a:srgbClr val="8FA3C7"/>
+                </a:solidFill>
+                <a:latin typeface="Share Tech Mono"/>
+              </a:rPr>
+              <a:t>  ·  </a:t>
+            </a:r>
+            <a:r>
+              <a:rPr sz="900" b="1">
+                <a:solidFill>
+                  <a:srgbClr val="FF2BD6"/>
+                </a:solidFill>
+                <a:latin typeface="Orbitron"/>
+              </a:rPr>
+              <a:t>&lt;LAB365&gt;</a:t>
+            </a:r>
+            <a:r>
+              <a:rPr sz="900" b="0">
+                <a:solidFill>
+                  <a:srgbClr val="8FA3C7"/>
+                </a:solidFill>
+                <a:latin typeface="Share Tech Mono"/>
+              </a:rPr>
+              <a:t>  ·  </a:t>
+            </a:r>
+            <a:r>
+              <a:rPr sz="900" b="1">
+                <a:solidFill>
+                  <a:srgbClr val="E6F7FF"/>
+                </a:solidFill>
+                <a:latin typeface="Orbitron"/>
+              </a:rPr>
               <a:t>SENAI</a:t>
             </a:r>
             <a:r>
-              <a:rPr sz="1000" b="0">
+              <a:rPr sz="900" b="0">
                 <a:solidFill>
                   <a:srgbClr val="8FA3C7"/>
                 </a:solidFill>
@@ -4869,13 +3596,13 @@
               <a:t>  ·  </a:t>
             </a:r>
             <a:r>
-              <a:rPr sz="1000" b="1">
-                <a:solidFill>
-                  <a:srgbClr val="FF2BD6"/>
+              <a:rPr sz="900" b="1">
+                <a:solidFill>
+                  <a:srgbClr val="E6F7FF"/>
                 </a:solidFill>
                 <a:latin typeface="Orbitron"/>
               </a:rPr>
-              <a:t>&lt;LAB365&gt;</a:t>
+              <a:t>SESI</a:t>
             </a:r>
           </a:p>
         </p:txBody>
@@ -4910,7 +3637,7 @@
                 </a:solidFill>
                 <a:latin typeface="Share Tech Mono"/>
               </a:rPr>
-              <a:t>3/5</a:t>
+              <a:t>3/6</a:t>
             </a:r>
           </a:p>
         </p:txBody>
@@ -5751,7 +4478,7 @@
                 </a:solidFill>
                 <a:latin typeface="Share Tech Mono"/>
               </a:rPr>
-              <a:t>03 // FISCALIZAÇÃO</a:t>
+              <a:t>02 // A SOLUÇÃO</a:t>
             </a:r>
           </a:p>
         </p:txBody>
@@ -5832,7 +4559,7 @@
                 </a:solidFill>
                 <a:latin typeface="Orbitron"/>
               </a:rPr>
-              <a:t>Quem passa do limite, para</a:t>
+              <a:t>Como a Autotec funciona</a:t>
             </a:r>
           </a:p>
         </p:txBody>
@@ -5952,7 +4679,7 @@
                 </a:solidFill>
                 <a:latin typeface="Share Tech Mono"/>
               </a:rPr>
-              <a:t>Se a scooter estava acima do limite, a roda traseira trava.</a:t>
+              <a:t>A scooter tem GPS e conhece as zonas de risco da cidade.</a:t>
             </a:r>
           </a:p>
         </p:txBody>
@@ -6072,7 +4799,7 @@
                 </a:solidFill>
                 <a:latin typeface="Share Tech Mono"/>
               </a:rPr>
-              <a:t>A polícia recebe um alerta e vai até o local desbloquear a scooter.</a:t>
+              <a:t>Perto da escola, ela desacelera sozinha e para antes da faixa de pedestres.</a:t>
             </a:r>
           </a:p>
         </p:txBody>
@@ -6192,7 +4919,7 @@
                 </a:solidFill>
                 <a:latin typeface="Share Tech Mono"/>
               </a:rPr>
-              <a:t>As autopeças instalam o sistema, e vamos propor as zonas à Câmara de Vereadores.</a:t>
+              <a:t>Quem estava no limite de velocidade segue viagem normalmente.</a:t>
             </a:r>
           </a:p>
         </p:txBody>
@@ -6206,7 +4933,7 @@
         <p:spPr>
           <a:xfrm>
             <a:off x="457200" y="4754880"/>
-            <a:ext cx="6400800" cy="228600"/>
+            <a:ext cx="7315200" cy="228600"/>
           </a:xfrm>
           <a:prstGeom prst="rect">
             <a:avLst/>
@@ -6221,7 +4948,7 @@
           <a:p>
             <a:pPr algn="l"/>
             <a:r>
-              <a:rPr sz="1000" b="1">
+              <a:rPr sz="900" b="1">
                 <a:solidFill>
                   <a:srgbClr val="22E6FF"/>
                 </a:solidFill>
@@ -6230,7 +4957,7 @@
               <a:t>RIO DO SUL MAIS TEC</a:t>
             </a:r>
             <a:r>
-              <a:rPr sz="1000" b="0">
+              <a:rPr sz="900" b="0">
                 <a:solidFill>
                   <a:srgbClr val="8FA3C7"/>
                 </a:solidFill>
@@ -6239,16 +4966,52 @@
               <a:t>  ·  </a:t>
             </a:r>
             <a:r>
-              <a:rPr sz="1000" b="1">
+              <a:rPr sz="900" b="1">
                 <a:solidFill>
                   <a:srgbClr val="E6F7FF"/>
                 </a:solidFill>
                 <a:latin typeface="Orbitron"/>
               </a:rPr>
+              <a:t>GOVERNO DE RIO DO SUL</a:t>
+            </a:r>
+            <a:r>
+              <a:rPr sz="900" b="0">
+                <a:solidFill>
+                  <a:srgbClr val="8FA3C7"/>
+                </a:solidFill>
+                <a:latin typeface="Share Tech Mono"/>
+              </a:rPr>
+              <a:t>  ·  </a:t>
+            </a:r>
+            <a:r>
+              <a:rPr sz="900" b="1">
+                <a:solidFill>
+                  <a:srgbClr val="FF2BD6"/>
+                </a:solidFill>
+                <a:latin typeface="Orbitron"/>
+              </a:rPr>
+              <a:t>&lt;LAB365&gt;</a:t>
+            </a:r>
+            <a:r>
+              <a:rPr sz="900" b="0">
+                <a:solidFill>
+                  <a:srgbClr val="8FA3C7"/>
+                </a:solidFill>
+                <a:latin typeface="Share Tech Mono"/>
+              </a:rPr>
+              <a:t>  ·  </a:t>
+            </a:r>
+            <a:r>
+              <a:rPr sz="900" b="1">
+                <a:solidFill>
+                  <a:srgbClr val="E6F7FF"/>
+                </a:solidFill>
+                <a:latin typeface="Orbitron"/>
+              </a:rPr>
               <a:t>SENAI</a:t>
             </a:r>
             <a:r>
-              <a:rPr sz="1000" b="0">
+              <a:rPr sz="900" b="0">
                 <a:solidFill>
                   <a:srgbClr val="8FA3C7"/>
                 </a:solidFill>
@@ -6257,13 +5020,13 @@
               <a:t>  ·  </a:t>
             </a:r>
             <a:r>
-              <a:rPr sz="1000" b="1">
-                <a:solidFill>
-                  <a:srgbClr val="FF2BD6"/>
+              <a:rPr sz="900" b="1">
+                <a:solidFill>
+                  <a:srgbClr val="E6F7FF"/>
                 </a:solidFill>
                 <a:latin typeface="Orbitron"/>
               </a:rPr>
-              <a:t>&lt;LAB365&gt;</a:t>
+              <a:t>SESI</a:t>
             </a:r>
           </a:p>
         </p:txBody>
@@ -6298,7 +5061,7 @@
                 </a:solidFill>
                 <a:latin typeface="Share Tech Mono"/>
               </a:rPr>
-              <a:t>4/5</a:t>
+              <a:t>4/6</a:t>
             </a:r>
           </a:p>
         </p:txBody>
@@ -7139,7 +5902,7 @@
                 </a:solidFill>
                 <a:latin typeface="Share Tech Mono"/>
               </a:rPr>
-              <a:t>04 // POR QUE A AUTOTEC</a:t>
+              <a:t>03 // FISCALIZAÇÃO</a:t>
             </a:r>
           </a:p>
         </p:txBody>
@@ -7220,7 +5983,7 @@
                 </a:solidFill>
                 <a:latin typeface="Orbitron"/>
               </a:rPr>
-              <a:t>Prevenir antes do primeiro acidente</a:t>
+              <a:t>Quem passa do limite, para</a:t>
             </a:r>
           </a:p>
         </p:txBody>
@@ -7340,7 +6103,7 @@
                 </a:solidFill>
                 <a:latin typeface="Share Tech Mono"/>
               </a:rPr>
-              <a:t>Protege as crianças e também os pilotos, que muitas vezes são adolescentes.</a:t>
+              <a:t>Se a scooter estava acima do limite, a roda traseira trava.</a:t>
             </a:r>
           </a:p>
         </p:txBody>
@@ -7460,7 +6223,7 @@
                 </a:solidFill>
                 <a:latin typeface="Share Tech Mono"/>
               </a:rPr>
-              <a:t>Ainda não há notícia de acidente aqui, e queremos que continue assim.</a:t>
+              <a:t>A polícia recebe um alerta e vai até o local desbloquear a scooter.</a:t>
             </a:r>
           </a:p>
         </p:txBody>
@@ -7580,7 +6343,7 @@
                 </a:solidFill>
                 <a:latin typeface="Share Tech Mono"/>
               </a:rPr>
-              <a:t>Autotec: a tecnologia de Rio do Sul a favor de quem atravessa.</a:t>
+              <a:t>As autopeças instalam o sistema, e vamos propor as zonas à Câmara de Vereadores.</a:t>
             </a:r>
           </a:p>
         </p:txBody>
@@ -7594,7 +6357,7 @@
         <p:spPr>
           <a:xfrm>
             <a:off x="457200" y="4754880"/>
-            <a:ext cx="6400800" cy="228600"/>
+            <a:ext cx="7315200" cy="228600"/>
           </a:xfrm>
           <a:prstGeom prst="rect">
             <a:avLst/>
@@ -7609,7 +6372,7 @@
           <a:p>
             <a:pPr algn="l"/>
             <a:r>
-              <a:rPr sz="1000" b="1">
+              <a:rPr sz="900" b="1">
                 <a:solidFill>
                   <a:srgbClr val="22E6FF"/>
                 </a:solidFill>
@@ -7618,7 +6381,7 @@
               <a:t>RIO DO SUL MAIS TEC</a:t>
             </a:r>
             <a:r>
-              <a:rPr sz="1000" b="0">
+              <a:rPr sz="900" b="0">
                 <a:solidFill>
                   <a:srgbClr val="8FA3C7"/>
                 </a:solidFill>
@@ -7627,16 +6390,52 @@
               <a:t>  ·  </a:t>
             </a:r>
             <a:r>
-              <a:rPr sz="1000" b="1">
+              <a:rPr sz="900" b="1">
                 <a:solidFill>
                   <a:srgbClr val="E6F7FF"/>
                 </a:solidFill>
                 <a:latin typeface="Orbitron"/>
               </a:rPr>
+              <a:t>GOVERNO DE RIO DO SUL</a:t>
+            </a:r>
+            <a:r>
+              <a:rPr sz="900" b="0">
+                <a:solidFill>
+                  <a:srgbClr val="8FA3C7"/>
+                </a:solidFill>
+                <a:latin typeface="Share Tech Mono"/>
+              </a:rPr>
+              <a:t>  ·  </a:t>
+            </a:r>
+            <a:r>
+              <a:rPr sz="900" b="1">
+                <a:solidFill>
+                  <a:srgbClr val="FF2BD6"/>
+                </a:solidFill>
+                <a:latin typeface="Orbitron"/>
+              </a:rPr>
+              <a:t>&lt;LAB365&gt;</a:t>
+            </a:r>
+            <a:r>
+              <a:rPr sz="900" b="0">
+                <a:solidFill>
+                  <a:srgbClr val="8FA3C7"/>
+                </a:solidFill>
+                <a:latin typeface="Share Tech Mono"/>
+              </a:rPr>
+              <a:t>  ·  </a:t>
+            </a:r>
+            <a:r>
+              <a:rPr sz="900" b="1">
+                <a:solidFill>
+                  <a:srgbClr val="E6F7FF"/>
+                </a:solidFill>
+                <a:latin typeface="Orbitron"/>
+              </a:rPr>
               <a:t>SENAI</a:t>
             </a:r>
             <a:r>
-              <a:rPr sz="1000" b="0">
+              <a:rPr sz="900" b="0">
                 <a:solidFill>
                   <a:srgbClr val="8FA3C7"/>
                 </a:solidFill>
@@ -7645,13 +6444,13 @@
               <a:t>  ·  </a:t>
             </a:r>
             <a:r>
-              <a:rPr sz="1000" b="1">
-                <a:solidFill>
-                  <a:srgbClr val="FF2BD6"/>
+              <a:rPr sz="900" b="1">
+                <a:solidFill>
+                  <a:srgbClr val="E6F7FF"/>
                 </a:solidFill>
                 <a:latin typeface="Orbitron"/>
               </a:rPr>
-              <a:t>&lt;LAB365&gt;</a:t>
+              <a:t>SESI</a:t>
             </a:r>
           </a:p>
         </p:txBody>
@@ -7686,7 +6485,1431 @@
                 </a:solidFill>
                 <a:latin typeface="Share Tech Mono"/>
               </a:rPr>
-              <a:t>5/5</a:t>
+              <a:t>5/6</a:t>
+            </a:r>
+          </a:p>
+        </p:txBody>
+      </p:sp>
+    </p:spTree>
+  </p:cSld>
+  <p:clrMapOvr>
+    <a:masterClrMapping/>
+  </p:clrMapOvr>
+</p:sld>
+</file>
+
+<file path=ppt/slides/slide6.xml><?xml version="1.0" encoding="utf-8"?>
+<p:sld xmlns:a="http://schemas.openxmlformats.org/drawingml/2006/main" xmlns:p="http://schemas.openxmlformats.org/presentationml/2006/main" xmlns:r="http://schemas.openxmlformats.org/officeDocument/2006/relationships">
+  <p:cSld>
+    <p:bg>
+      <p:bgPr>
+        <a:solidFill>
+          <a:srgbClr val="05030D"/>
+        </a:solidFill>
+        <a:effectLst/>
+      </p:bgPr>
+    </p:bg>
+    <p:spTree>
+      <p:nvGrpSpPr>
+        <p:cNvPr id="1" name=""/>
+        <p:cNvGrpSpPr/>
+        <p:nvPr/>
+      </p:nvGrpSpPr>
+      <p:grpSpPr/>
+      <p:sp>
+        <p:nvSpPr>
+          <p:cNvPr id="2" name="Oval 1"/>
+          <p:cNvSpPr/>
+          <p:nvPr/>
+        </p:nvSpPr>
+        <p:spPr>
+          <a:xfrm>
+            <a:off x="-1371600" y="-1645920"/>
+            <a:ext cx="5029200" cy="4114800"/>
+          </a:xfrm>
+          <a:prstGeom prst="ellipse">
+            <a:avLst/>
+          </a:prstGeom>
+          <a:solidFill>
+            <a:srgbClr val="7B2CFF">
+              <a:alpha val="22000"/>
+            </a:srgbClr>
+          </a:solidFill>
+          <a:ln>
+            <a:noFill/>
+          </a:ln>
+          <a:effectLst/>
+        </p:spPr>
+        <p:style>
+          <a:lnRef idx="1">
+            <a:schemeClr val="accent1"/>
+          </a:lnRef>
+          <a:fillRef idx="3">
+            <a:schemeClr val="accent1"/>
+          </a:fillRef>
+          <a:effectRef idx="2">
+            <a:schemeClr val="accent1"/>
+          </a:effectRef>
+          <a:fontRef idx="minor">
+            <a:schemeClr val="lt1"/>
+          </a:fontRef>
+        </p:style>
+        <p:txBody>
+          <a:bodyPr rtlCol="0" anchor="ctr"/>
+          <a:lstStyle/>
+          <a:p>
+            <a:pPr algn="ctr"/>
+          </a:p>
+        </p:txBody>
+      </p:sp>
+      <p:sp>
+        <p:nvSpPr>
+          <p:cNvPr id="3" name="Oval 2"/>
+          <p:cNvSpPr/>
+          <p:nvPr/>
+        </p:nvSpPr>
+        <p:spPr>
+          <a:xfrm>
+            <a:off x="6400800" y="3108960"/>
+            <a:ext cx="4114800" cy="3200400"/>
+          </a:xfrm>
+          <a:prstGeom prst="ellipse">
+            <a:avLst/>
+          </a:prstGeom>
+          <a:solidFill>
+            <a:srgbClr val="FF2BD6">
+              <a:alpha val="14000"/>
+            </a:srgbClr>
+          </a:solidFill>
+          <a:ln>
+            <a:noFill/>
+          </a:ln>
+          <a:effectLst/>
+        </p:spPr>
+        <p:style>
+          <a:lnRef idx="1">
+            <a:schemeClr val="accent1"/>
+          </a:lnRef>
+          <a:fillRef idx="3">
+            <a:schemeClr val="accent1"/>
+          </a:fillRef>
+          <a:effectRef idx="2">
+            <a:schemeClr val="accent1"/>
+          </a:effectRef>
+          <a:fontRef idx="minor">
+            <a:schemeClr val="lt1"/>
+          </a:fontRef>
+        </p:style>
+        <p:txBody>
+          <a:bodyPr rtlCol="0" anchor="ctr"/>
+          <a:lstStyle/>
+          <a:p>
+            <a:pPr algn="ctr"/>
+          </a:p>
+        </p:txBody>
+      </p:sp>
+      <p:sp>
+        <p:nvSpPr>
+          <p:cNvPr id="4" name="Rectangle 3"/>
+          <p:cNvSpPr/>
+          <p:nvPr/>
+        </p:nvSpPr>
+        <p:spPr>
+          <a:xfrm>
+            <a:off x="914400" y="0"/>
+            <a:ext cx="9144" cy="5143500"/>
+          </a:xfrm>
+          <a:prstGeom prst="rect">
+            <a:avLst/>
+          </a:prstGeom>
+          <a:solidFill>
+            <a:srgbClr val="22E6FF">
+              <a:alpha val="6000"/>
+            </a:srgbClr>
+          </a:solidFill>
+          <a:ln>
+            <a:noFill/>
+          </a:ln>
+          <a:effectLst/>
+        </p:spPr>
+        <p:style>
+          <a:lnRef idx="1">
+            <a:schemeClr val="accent1"/>
+          </a:lnRef>
+          <a:fillRef idx="3">
+            <a:schemeClr val="accent1"/>
+          </a:fillRef>
+          <a:effectRef idx="2">
+            <a:schemeClr val="accent1"/>
+          </a:effectRef>
+          <a:fontRef idx="minor">
+            <a:schemeClr val="lt1"/>
+          </a:fontRef>
+        </p:style>
+        <p:txBody>
+          <a:bodyPr rtlCol="0" anchor="ctr"/>
+          <a:lstStyle/>
+          <a:p>
+            <a:pPr algn="ctr"/>
+          </a:p>
+        </p:txBody>
+      </p:sp>
+      <p:sp>
+        <p:nvSpPr>
+          <p:cNvPr id="5" name="Rectangle 4"/>
+          <p:cNvSpPr/>
+          <p:nvPr/>
+        </p:nvSpPr>
+        <p:spPr>
+          <a:xfrm>
+            <a:off x="1828800" y="0"/>
+            <a:ext cx="9144" cy="5143500"/>
+          </a:xfrm>
+          <a:prstGeom prst="rect">
+            <a:avLst/>
+          </a:prstGeom>
+          <a:solidFill>
+            <a:srgbClr val="22E6FF">
+              <a:alpha val="6000"/>
+            </a:srgbClr>
+          </a:solidFill>
+          <a:ln>
+            <a:noFill/>
+          </a:ln>
+          <a:effectLst/>
+        </p:spPr>
+        <p:style>
+          <a:lnRef idx="1">
+            <a:schemeClr val="accent1"/>
+          </a:lnRef>
+          <a:fillRef idx="3">
+            <a:schemeClr val="accent1"/>
+          </a:fillRef>
+          <a:effectRef idx="2">
+            <a:schemeClr val="accent1"/>
+          </a:effectRef>
+          <a:fontRef idx="minor">
+            <a:schemeClr val="lt1"/>
+          </a:fontRef>
+        </p:style>
+        <p:txBody>
+          <a:bodyPr rtlCol="0" anchor="ctr"/>
+          <a:lstStyle/>
+          <a:p>
+            <a:pPr algn="ctr"/>
+          </a:p>
+        </p:txBody>
+      </p:sp>
+      <p:sp>
+        <p:nvSpPr>
+          <p:cNvPr id="6" name="Rectangle 5"/>
+          <p:cNvSpPr/>
+          <p:nvPr/>
+        </p:nvSpPr>
+        <p:spPr>
+          <a:xfrm>
+            <a:off x="2743200" y="0"/>
+            <a:ext cx="9144" cy="5143500"/>
+          </a:xfrm>
+          <a:prstGeom prst="rect">
+            <a:avLst/>
+          </a:prstGeom>
+          <a:solidFill>
+            <a:srgbClr val="22E6FF">
+              <a:alpha val="6000"/>
+            </a:srgbClr>
+          </a:solidFill>
+          <a:ln>
+            <a:noFill/>
+          </a:ln>
+          <a:effectLst/>
+        </p:spPr>
+        <p:style>
+          <a:lnRef idx="1">
+            <a:schemeClr val="accent1"/>
+          </a:lnRef>
+          <a:fillRef idx="3">
+            <a:schemeClr val="accent1"/>
+          </a:fillRef>
+          <a:effectRef idx="2">
+            <a:schemeClr val="accent1"/>
+          </a:effectRef>
+          <a:fontRef idx="minor">
+            <a:schemeClr val="lt1"/>
+          </a:fontRef>
+        </p:style>
+        <p:txBody>
+          <a:bodyPr rtlCol="0" anchor="ctr"/>
+          <a:lstStyle/>
+          <a:p>
+            <a:pPr algn="ctr"/>
+          </a:p>
+        </p:txBody>
+      </p:sp>
+      <p:sp>
+        <p:nvSpPr>
+          <p:cNvPr id="7" name="Rectangle 6"/>
+          <p:cNvSpPr/>
+          <p:nvPr/>
+        </p:nvSpPr>
+        <p:spPr>
+          <a:xfrm>
+            <a:off x="3657600" y="0"/>
+            <a:ext cx="9144" cy="5143500"/>
+          </a:xfrm>
+          <a:prstGeom prst="rect">
+            <a:avLst/>
+          </a:prstGeom>
+          <a:solidFill>
+            <a:srgbClr val="22E6FF">
+              <a:alpha val="6000"/>
+            </a:srgbClr>
+          </a:solidFill>
+          <a:ln>
+            <a:noFill/>
+          </a:ln>
+          <a:effectLst/>
+        </p:spPr>
+        <p:style>
+          <a:lnRef idx="1">
+            <a:schemeClr val="accent1"/>
+          </a:lnRef>
+          <a:fillRef idx="3">
+            <a:schemeClr val="accent1"/>
+          </a:fillRef>
+          <a:effectRef idx="2">
+            <a:schemeClr val="accent1"/>
+          </a:effectRef>
+          <a:fontRef idx="minor">
+            <a:schemeClr val="lt1"/>
+          </a:fontRef>
+        </p:style>
+        <p:txBody>
+          <a:bodyPr rtlCol="0" anchor="ctr"/>
+          <a:lstStyle/>
+          <a:p>
+            <a:pPr algn="ctr"/>
+          </a:p>
+        </p:txBody>
+      </p:sp>
+      <p:sp>
+        <p:nvSpPr>
+          <p:cNvPr id="8" name="Rectangle 7"/>
+          <p:cNvSpPr/>
+          <p:nvPr/>
+        </p:nvSpPr>
+        <p:spPr>
+          <a:xfrm>
+            <a:off x="4572000" y="0"/>
+            <a:ext cx="9144" cy="5143500"/>
+          </a:xfrm>
+          <a:prstGeom prst="rect">
+            <a:avLst/>
+          </a:prstGeom>
+          <a:solidFill>
+            <a:srgbClr val="22E6FF">
+              <a:alpha val="6000"/>
+            </a:srgbClr>
+          </a:solidFill>
+          <a:ln>
+            <a:noFill/>
+          </a:ln>
+          <a:effectLst/>
+        </p:spPr>
+        <p:style>
+          <a:lnRef idx="1">
+            <a:schemeClr val="accent1"/>
+          </a:lnRef>
+          <a:fillRef idx="3">
+            <a:schemeClr val="accent1"/>
+          </a:fillRef>
+          <a:effectRef idx="2">
+            <a:schemeClr val="accent1"/>
+          </a:effectRef>
+          <a:fontRef idx="minor">
+            <a:schemeClr val="lt1"/>
+          </a:fontRef>
+        </p:style>
+        <p:txBody>
+          <a:bodyPr rtlCol="0" anchor="ctr"/>
+          <a:lstStyle/>
+          <a:p>
+            <a:pPr algn="ctr"/>
+          </a:p>
+        </p:txBody>
+      </p:sp>
+      <p:sp>
+        <p:nvSpPr>
+          <p:cNvPr id="9" name="Rectangle 8"/>
+          <p:cNvSpPr/>
+          <p:nvPr/>
+        </p:nvSpPr>
+        <p:spPr>
+          <a:xfrm>
+            <a:off x="5486400" y="0"/>
+            <a:ext cx="9144" cy="5143500"/>
+          </a:xfrm>
+          <a:prstGeom prst="rect">
+            <a:avLst/>
+          </a:prstGeom>
+          <a:solidFill>
+            <a:srgbClr val="22E6FF">
+              <a:alpha val="6000"/>
+            </a:srgbClr>
+          </a:solidFill>
+          <a:ln>
+            <a:noFill/>
+          </a:ln>
+          <a:effectLst/>
+        </p:spPr>
+        <p:style>
+          <a:lnRef idx="1">
+            <a:schemeClr val="accent1"/>
+          </a:lnRef>
+          <a:fillRef idx="3">
+            <a:schemeClr val="accent1"/>
+          </a:fillRef>
+          <a:effectRef idx="2">
+            <a:schemeClr val="accent1"/>
+          </a:effectRef>
+          <a:fontRef idx="minor">
+            <a:schemeClr val="lt1"/>
+          </a:fontRef>
+        </p:style>
+        <p:txBody>
+          <a:bodyPr rtlCol="0" anchor="ctr"/>
+          <a:lstStyle/>
+          <a:p>
+            <a:pPr algn="ctr"/>
+          </a:p>
+        </p:txBody>
+      </p:sp>
+      <p:sp>
+        <p:nvSpPr>
+          <p:cNvPr id="10" name="Rectangle 9"/>
+          <p:cNvSpPr/>
+          <p:nvPr/>
+        </p:nvSpPr>
+        <p:spPr>
+          <a:xfrm>
+            <a:off x="6400800" y="0"/>
+            <a:ext cx="9144" cy="5143500"/>
+          </a:xfrm>
+          <a:prstGeom prst="rect">
+            <a:avLst/>
+          </a:prstGeom>
+          <a:solidFill>
+            <a:srgbClr val="22E6FF">
+              <a:alpha val="6000"/>
+            </a:srgbClr>
+          </a:solidFill>
+          <a:ln>
+            <a:noFill/>
+          </a:ln>
+          <a:effectLst/>
+        </p:spPr>
+        <p:style>
+          <a:lnRef idx="1">
+            <a:schemeClr val="accent1"/>
+          </a:lnRef>
+          <a:fillRef idx="3">
+            <a:schemeClr val="accent1"/>
+          </a:fillRef>
+          <a:effectRef idx="2">
+            <a:schemeClr val="accent1"/>
+          </a:effectRef>
+          <a:fontRef idx="minor">
+            <a:schemeClr val="lt1"/>
+          </a:fontRef>
+        </p:style>
+        <p:txBody>
+          <a:bodyPr rtlCol="0" anchor="ctr"/>
+          <a:lstStyle/>
+          <a:p>
+            <a:pPr algn="ctr"/>
+          </a:p>
+        </p:txBody>
+      </p:sp>
+      <p:sp>
+        <p:nvSpPr>
+          <p:cNvPr id="11" name="Rectangle 10"/>
+          <p:cNvSpPr/>
+          <p:nvPr/>
+        </p:nvSpPr>
+        <p:spPr>
+          <a:xfrm>
+            <a:off x="7315200" y="0"/>
+            <a:ext cx="9144" cy="5143500"/>
+          </a:xfrm>
+          <a:prstGeom prst="rect">
+            <a:avLst/>
+          </a:prstGeom>
+          <a:solidFill>
+            <a:srgbClr val="22E6FF">
+              <a:alpha val="6000"/>
+            </a:srgbClr>
+          </a:solidFill>
+          <a:ln>
+            <a:noFill/>
+          </a:ln>
+          <a:effectLst/>
+        </p:spPr>
+        <p:style>
+          <a:lnRef idx="1">
+            <a:schemeClr val="accent1"/>
+          </a:lnRef>
+          <a:fillRef idx="3">
+            <a:schemeClr val="accent1"/>
+          </a:fillRef>
+          <a:effectRef idx="2">
+            <a:schemeClr val="accent1"/>
+          </a:effectRef>
+          <a:fontRef idx="minor">
+            <a:schemeClr val="lt1"/>
+          </a:fontRef>
+        </p:style>
+        <p:txBody>
+          <a:bodyPr rtlCol="0" anchor="ctr"/>
+          <a:lstStyle/>
+          <a:p>
+            <a:pPr algn="ctr"/>
+          </a:p>
+        </p:txBody>
+      </p:sp>
+      <p:sp>
+        <p:nvSpPr>
+          <p:cNvPr id="12" name="Rectangle 11"/>
+          <p:cNvSpPr/>
+          <p:nvPr/>
+        </p:nvSpPr>
+        <p:spPr>
+          <a:xfrm>
+            <a:off x="8229600" y="0"/>
+            <a:ext cx="9144" cy="5143500"/>
+          </a:xfrm>
+          <a:prstGeom prst="rect">
+            <a:avLst/>
+          </a:prstGeom>
+          <a:solidFill>
+            <a:srgbClr val="22E6FF">
+              <a:alpha val="6000"/>
+            </a:srgbClr>
+          </a:solidFill>
+          <a:ln>
+            <a:noFill/>
+          </a:ln>
+          <a:effectLst/>
+        </p:spPr>
+        <p:style>
+          <a:lnRef idx="1">
+            <a:schemeClr val="accent1"/>
+          </a:lnRef>
+          <a:fillRef idx="3">
+            <a:schemeClr val="accent1"/>
+          </a:fillRef>
+          <a:effectRef idx="2">
+            <a:schemeClr val="accent1"/>
+          </a:effectRef>
+          <a:fontRef idx="minor">
+            <a:schemeClr val="lt1"/>
+          </a:fontRef>
+        </p:style>
+        <p:txBody>
+          <a:bodyPr rtlCol="0" anchor="ctr"/>
+          <a:lstStyle/>
+          <a:p>
+            <a:pPr algn="ctr"/>
+          </a:p>
+        </p:txBody>
+      </p:sp>
+      <p:sp>
+        <p:nvSpPr>
+          <p:cNvPr id="13" name="Rectangle 12"/>
+          <p:cNvSpPr/>
+          <p:nvPr/>
+        </p:nvSpPr>
+        <p:spPr>
+          <a:xfrm>
+            <a:off x="0" y="914400"/>
+            <a:ext cx="9144000" cy="9144"/>
+          </a:xfrm>
+          <a:prstGeom prst="rect">
+            <a:avLst/>
+          </a:prstGeom>
+          <a:solidFill>
+            <a:srgbClr val="22E6FF">
+              <a:alpha val="6000"/>
+            </a:srgbClr>
+          </a:solidFill>
+          <a:ln>
+            <a:noFill/>
+          </a:ln>
+          <a:effectLst/>
+        </p:spPr>
+        <p:style>
+          <a:lnRef idx="1">
+            <a:schemeClr val="accent1"/>
+          </a:lnRef>
+          <a:fillRef idx="3">
+            <a:schemeClr val="accent1"/>
+          </a:fillRef>
+          <a:effectRef idx="2">
+            <a:schemeClr val="accent1"/>
+          </a:effectRef>
+          <a:fontRef idx="minor">
+            <a:schemeClr val="lt1"/>
+          </a:fontRef>
+        </p:style>
+        <p:txBody>
+          <a:bodyPr rtlCol="0" anchor="ctr"/>
+          <a:lstStyle/>
+          <a:p>
+            <a:pPr algn="ctr"/>
+          </a:p>
+        </p:txBody>
+      </p:sp>
+      <p:sp>
+        <p:nvSpPr>
+          <p:cNvPr id="14" name="Rectangle 13"/>
+          <p:cNvSpPr/>
+          <p:nvPr/>
+        </p:nvSpPr>
+        <p:spPr>
+          <a:xfrm>
+            <a:off x="0" y="1828800"/>
+            <a:ext cx="9144000" cy="9144"/>
+          </a:xfrm>
+          <a:prstGeom prst="rect">
+            <a:avLst/>
+          </a:prstGeom>
+          <a:solidFill>
+            <a:srgbClr val="22E6FF">
+              <a:alpha val="6000"/>
+            </a:srgbClr>
+          </a:solidFill>
+          <a:ln>
+            <a:noFill/>
+          </a:ln>
+          <a:effectLst/>
+        </p:spPr>
+        <p:style>
+          <a:lnRef idx="1">
+            <a:schemeClr val="accent1"/>
+          </a:lnRef>
+          <a:fillRef idx="3">
+            <a:schemeClr val="accent1"/>
+          </a:fillRef>
+          <a:effectRef idx="2">
+            <a:schemeClr val="accent1"/>
+          </a:effectRef>
+          <a:fontRef idx="minor">
+            <a:schemeClr val="lt1"/>
+          </a:fontRef>
+        </p:style>
+        <p:txBody>
+          <a:bodyPr rtlCol="0" anchor="ctr"/>
+          <a:lstStyle/>
+          <a:p>
+            <a:pPr algn="ctr"/>
+          </a:p>
+        </p:txBody>
+      </p:sp>
+      <p:sp>
+        <p:nvSpPr>
+          <p:cNvPr id="15" name="Rectangle 14"/>
+          <p:cNvSpPr/>
+          <p:nvPr/>
+        </p:nvSpPr>
+        <p:spPr>
+          <a:xfrm>
+            <a:off x="0" y="2743200"/>
+            <a:ext cx="9144000" cy="9144"/>
+          </a:xfrm>
+          <a:prstGeom prst="rect">
+            <a:avLst/>
+          </a:prstGeom>
+          <a:solidFill>
+            <a:srgbClr val="22E6FF">
+              <a:alpha val="6000"/>
+            </a:srgbClr>
+          </a:solidFill>
+          <a:ln>
+            <a:noFill/>
+          </a:ln>
+          <a:effectLst/>
+        </p:spPr>
+        <p:style>
+          <a:lnRef idx="1">
+            <a:schemeClr val="accent1"/>
+          </a:lnRef>
+          <a:fillRef idx="3">
+            <a:schemeClr val="accent1"/>
+          </a:fillRef>
+          <a:effectRef idx="2">
+            <a:schemeClr val="accent1"/>
+          </a:effectRef>
+          <a:fontRef idx="minor">
+            <a:schemeClr val="lt1"/>
+          </a:fontRef>
+        </p:style>
+        <p:txBody>
+          <a:bodyPr rtlCol="0" anchor="ctr"/>
+          <a:lstStyle/>
+          <a:p>
+            <a:pPr algn="ctr"/>
+          </a:p>
+        </p:txBody>
+      </p:sp>
+      <p:sp>
+        <p:nvSpPr>
+          <p:cNvPr id="16" name="Rectangle 15"/>
+          <p:cNvSpPr/>
+          <p:nvPr/>
+        </p:nvSpPr>
+        <p:spPr>
+          <a:xfrm>
+            <a:off x="0" y="3657600"/>
+            <a:ext cx="9144000" cy="9144"/>
+          </a:xfrm>
+          <a:prstGeom prst="rect">
+            <a:avLst/>
+          </a:prstGeom>
+          <a:solidFill>
+            <a:srgbClr val="22E6FF">
+              <a:alpha val="6000"/>
+            </a:srgbClr>
+          </a:solidFill>
+          <a:ln>
+            <a:noFill/>
+          </a:ln>
+          <a:effectLst/>
+        </p:spPr>
+        <p:style>
+          <a:lnRef idx="1">
+            <a:schemeClr val="accent1"/>
+          </a:lnRef>
+          <a:fillRef idx="3">
+            <a:schemeClr val="accent1"/>
+          </a:fillRef>
+          <a:effectRef idx="2">
+            <a:schemeClr val="accent1"/>
+          </a:effectRef>
+          <a:fontRef idx="minor">
+            <a:schemeClr val="lt1"/>
+          </a:fontRef>
+        </p:style>
+        <p:txBody>
+          <a:bodyPr rtlCol="0" anchor="ctr"/>
+          <a:lstStyle/>
+          <a:p>
+            <a:pPr algn="ctr"/>
+          </a:p>
+        </p:txBody>
+      </p:sp>
+      <p:sp>
+        <p:nvSpPr>
+          <p:cNvPr id="17" name="Rectangle 16"/>
+          <p:cNvSpPr/>
+          <p:nvPr/>
+        </p:nvSpPr>
+        <p:spPr>
+          <a:xfrm>
+            <a:off x="0" y="4572000"/>
+            <a:ext cx="9144000" cy="9144"/>
+          </a:xfrm>
+          <a:prstGeom prst="rect">
+            <a:avLst/>
+          </a:prstGeom>
+          <a:solidFill>
+            <a:srgbClr val="22E6FF">
+              <a:alpha val="6000"/>
+            </a:srgbClr>
+          </a:solidFill>
+          <a:ln>
+            <a:noFill/>
+          </a:ln>
+          <a:effectLst/>
+        </p:spPr>
+        <p:style>
+          <a:lnRef idx="1">
+            <a:schemeClr val="accent1"/>
+          </a:lnRef>
+          <a:fillRef idx="3">
+            <a:schemeClr val="accent1"/>
+          </a:fillRef>
+          <a:effectRef idx="2">
+            <a:schemeClr val="accent1"/>
+          </a:effectRef>
+          <a:fontRef idx="minor">
+            <a:schemeClr val="lt1"/>
+          </a:fontRef>
+        </p:style>
+        <p:txBody>
+          <a:bodyPr rtlCol="0" anchor="ctr"/>
+          <a:lstStyle/>
+          <a:p>
+            <a:pPr algn="ctr"/>
+          </a:p>
+        </p:txBody>
+      </p:sp>
+      <p:sp>
+        <p:nvSpPr>
+          <p:cNvPr id="18" name="TextBox 17"/>
+          <p:cNvSpPr txBox="1"/>
+          <p:nvPr/>
+        </p:nvSpPr>
+        <p:spPr>
+          <a:xfrm>
+            <a:off x="457200" y="274320"/>
+            <a:ext cx="5486400" cy="274320"/>
+          </a:xfrm>
+          <a:prstGeom prst="rect">
+            <a:avLst/>
+          </a:prstGeom>
+          <a:noFill/>
+        </p:spPr>
+        <p:txBody>
+          <a:bodyPr wrap="square" anchor="t" lIns="0" rIns="0" tIns="0" bIns="0">
+            <a:spAutoFit/>
+          </a:bodyPr>
+          <a:lstStyle/>
+          <a:p>
+            <a:pPr algn="l"/>
+            <a:r>
+              <a:rPr sz="1300" b="1">
+                <a:solidFill>
+                  <a:srgbClr val="E6F7FF"/>
+                </a:solidFill>
+                <a:latin typeface="Orbitron"/>
+              </a:rPr>
+              <a:t>RIO DO SUL </a:t>
+            </a:r>
+            <a:r>
+              <a:rPr sz="1300" b="1">
+                <a:solidFill>
+                  <a:srgbClr val="22E6FF"/>
+                </a:solidFill>
+                <a:latin typeface="Orbitron"/>
+              </a:rPr>
+              <a:t>MAIS TEC</a:t>
+            </a:r>
+          </a:p>
+        </p:txBody>
+      </p:sp>
+      <p:sp>
+        <p:nvSpPr>
+          <p:cNvPr id="19" name="TextBox 18"/>
+          <p:cNvSpPr txBox="1"/>
+          <p:nvPr/>
+        </p:nvSpPr>
+        <p:spPr>
+          <a:xfrm>
+            <a:off x="5486400" y="292608"/>
+            <a:ext cx="3200400" cy="274320"/>
+          </a:xfrm>
+          <a:prstGeom prst="rect">
+            <a:avLst/>
+          </a:prstGeom>
+          <a:noFill/>
+        </p:spPr>
+        <p:txBody>
+          <a:bodyPr wrap="square" anchor="t" lIns="0" rIns="0" tIns="0" bIns="0">
+            <a:spAutoFit/>
+          </a:bodyPr>
+          <a:lstStyle/>
+          <a:p>
+            <a:pPr algn="r"/>
+            <a:r>
+              <a:rPr sz="1000" b="0">
+                <a:solidFill>
+                  <a:srgbClr val="FF2BD6"/>
+                </a:solidFill>
+                <a:latin typeface="Share Tech Mono"/>
+              </a:rPr>
+              <a:t>04 // POR QUE A AUTOTEC</a:t>
+            </a:r>
+          </a:p>
+        </p:txBody>
+      </p:sp>
+      <p:sp>
+        <p:nvSpPr>
+          <p:cNvPr id="20" name="Rectangle 19"/>
+          <p:cNvSpPr/>
+          <p:nvPr/>
+        </p:nvSpPr>
+        <p:spPr>
+          <a:xfrm>
+            <a:off x="457200" y="621792"/>
+            <a:ext cx="8229600" cy="18288"/>
+          </a:xfrm>
+          <a:prstGeom prst="rect">
+            <a:avLst/>
+          </a:prstGeom>
+          <a:solidFill>
+            <a:srgbClr val="22E6FF">
+              <a:alpha val="70000"/>
+            </a:srgbClr>
+          </a:solidFill>
+          <a:ln>
+            <a:noFill/>
+          </a:ln>
+          <a:effectLst/>
+        </p:spPr>
+        <p:style>
+          <a:lnRef idx="1">
+            <a:schemeClr val="accent1"/>
+          </a:lnRef>
+          <a:fillRef idx="3">
+            <a:schemeClr val="accent1"/>
+          </a:fillRef>
+          <a:effectRef idx="2">
+            <a:schemeClr val="accent1"/>
+          </a:effectRef>
+          <a:fontRef idx="minor">
+            <a:schemeClr val="lt1"/>
+          </a:fontRef>
+        </p:style>
+        <p:txBody>
+          <a:bodyPr rtlCol="0" anchor="ctr"/>
+          <a:lstStyle/>
+          <a:p>
+            <a:pPr algn="ctr"/>
+          </a:p>
+        </p:txBody>
+      </p:sp>
+      <p:sp>
+        <p:nvSpPr>
+          <p:cNvPr id="21" name="TextBox 20"/>
+          <p:cNvSpPr txBox="1"/>
+          <p:nvPr/>
+        </p:nvSpPr>
+        <p:spPr>
+          <a:xfrm>
+            <a:off x="457200" y="822960"/>
+            <a:ext cx="8229600" cy="640080"/>
+          </a:xfrm>
+          <a:prstGeom prst="rect">
+            <a:avLst/>
+          </a:prstGeom>
+          <a:noFill/>
+        </p:spPr>
+        <p:txBody>
+          <a:bodyPr wrap="square" anchor="t" lIns="0" rIns="0" tIns="0" bIns="0">
+            <a:spAutoFit/>
+          </a:bodyPr>
+          <a:lstStyle/>
+          <a:p>
+            <a:pPr algn="l"/>
+            <a:r>
+              <a:rPr sz="2600" b="1">
+                <a:solidFill>
+                  <a:srgbClr val="E6F7FF"/>
+                </a:solidFill>
+                <a:latin typeface="Orbitron"/>
+              </a:rPr>
+              <a:t>Prevenir antes do primeiro acidente</a:t>
+            </a:r>
+          </a:p>
+        </p:txBody>
+      </p:sp>
+      <p:sp>
+        <p:nvSpPr>
+          <p:cNvPr id="22" name="Rounded Rectangle 21"/>
+          <p:cNvSpPr/>
+          <p:nvPr/>
+        </p:nvSpPr>
+        <p:spPr>
+          <a:xfrm>
+            <a:off x="457200" y="1600200"/>
+            <a:ext cx="8229600" cy="804672"/>
+          </a:xfrm>
+          <a:prstGeom prst="roundRect">
+            <a:avLst>
+              <a:gd name="adj" fmla="val 18000"/>
+            </a:avLst>
+          </a:prstGeom>
+          <a:solidFill>
+            <a:srgbClr val="100A24">
+              <a:alpha val="85000"/>
+            </a:srgbClr>
+          </a:solidFill>
+          <a:ln w="15875">
+            <a:solidFill>
+              <a:srgbClr val="22E6FF"/>
+            </a:solidFill>
+          </a:ln>
+          <a:effectLst/>
+        </p:spPr>
+        <p:style>
+          <a:lnRef idx="1">
+            <a:schemeClr val="accent1"/>
+          </a:lnRef>
+          <a:fillRef idx="3">
+            <a:schemeClr val="accent1"/>
+          </a:fillRef>
+          <a:effectRef idx="2">
+            <a:schemeClr val="accent1"/>
+          </a:effectRef>
+          <a:fontRef idx="minor">
+            <a:schemeClr val="lt1"/>
+          </a:fontRef>
+        </p:style>
+        <p:txBody>
+          <a:bodyPr rtlCol="0" anchor="ctr"/>
+          <a:lstStyle/>
+          <a:p>
+            <a:pPr algn="ctr"/>
+          </a:p>
+        </p:txBody>
+      </p:sp>
+      <p:sp>
+        <p:nvSpPr>
+          <p:cNvPr id="23" name="TextBox 22"/>
+          <p:cNvSpPr txBox="1"/>
+          <p:nvPr/>
+        </p:nvSpPr>
+        <p:spPr>
+          <a:xfrm>
+            <a:off x="685800" y="1600200"/>
+            <a:ext cx="548640" cy="804672"/>
+          </a:xfrm>
+          <a:prstGeom prst="rect">
+            <a:avLst/>
+          </a:prstGeom>
+          <a:noFill/>
+        </p:spPr>
+        <p:txBody>
+          <a:bodyPr wrap="square" anchor="ctr" lIns="0" rIns="0" tIns="0" bIns="0">
+            <a:spAutoFit/>
+          </a:bodyPr>
+          <a:lstStyle/>
+          <a:p>
+            <a:pPr algn="l"/>
+            <a:r>
+              <a:rPr sz="1600" b="1">
+                <a:solidFill>
+                  <a:srgbClr val="FF2BD6"/>
+                </a:solidFill>
+                <a:latin typeface="Orbitron"/>
+              </a:rPr>
+              <a:t>01</a:t>
+            </a:r>
+          </a:p>
+        </p:txBody>
+      </p:sp>
+      <p:sp>
+        <p:nvSpPr>
+          <p:cNvPr id="24" name="TextBox 23"/>
+          <p:cNvSpPr txBox="1"/>
+          <p:nvPr/>
+        </p:nvSpPr>
+        <p:spPr>
+          <a:xfrm>
+            <a:off x="1280160" y="1645920"/>
+            <a:ext cx="7223760" cy="713232"/>
+          </a:xfrm>
+          <a:prstGeom prst="rect">
+            <a:avLst/>
+          </a:prstGeom>
+          <a:noFill/>
+        </p:spPr>
+        <p:txBody>
+          <a:bodyPr wrap="square" anchor="ctr" lIns="0" rIns="0" tIns="0" bIns="0">
+            <a:spAutoFit/>
+          </a:bodyPr>
+          <a:lstStyle/>
+          <a:p>
+            <a:pPr algn="l"/>
+            <a:r>
+              <a:rPr sz="1800" b="0">
+                <a:solidFill>
+                  <a:srgbClr val="E6F7FF"/>
+                </a:solidFill>
+                <a:latin typeface="Share Tech Mono"/>
+              </a:rPr>
+              <a:t>Protege as crianças e também os pilotos, que muitas vezes são adolescentes.</a:t>
+            </a:r>
+          </a:p>
+        </p:txBody>
+      </p:sp>
+      <p:sp>
+        <p:nvSpPr>
+          <p:cNvPr id="25" name="Rounded Rectangle 24"/>
+          <p:cNvSpPr/>
+          <p:nvPr/>
+        </p:nvSpPr>
+        <p:spPr>
+          <a:xfrm>
+            <a:off x="457200" y="2569464"/>
+            <a:ext cx="8229600" cy="804672"/>
+          </a:xfrm>
+          <a:prstGeom prst="roundRect">
+            <a:avLst>
+              <a:gd name="adj" fmla="val 18000"/>
+            </a:avLst>
+          </a:prstGeom>
+          <a:solidFill>
+            <a:srgbClr val="100A24">
+              <a:alpha val="85000"/>
+            </a:srgbClr>
+          </a:solidFill>
+          <a:ln w="15875">
+            <a:solidFill>
+              <a:srgbClr val="22E6FF"/>
+            </a:solidFill>
+          </a:ln>
+          <a:effectLst/>
+        </p:spPr>
+        <p:style>
+          <a:lnRef idx="1">
+            <a:schemeClr val="accent1"/>
+          </a:lnRef>
+          <a:fillRef idx="3">
+            <a:schemeClr val="accent1"/>
+          </a:fillRef>
+          <a:effectRef idx="2">
+            <a:schemeClr val="accent1"/>
+          </a:effectRef>
+          <a:fontRef idx="minor">
+            <a:schemeClr val="lt1"/>
+          </a:fontRef>
+        </p:style>
+        <p:txBody>
+          <a:bodyPr rtlCol="0" anchor="ctr"/>
+          <a:lstStyle/>
+          <a:p>
+            <a:pPr algn="ctr"/>
+          </a:p>
+        </p:txBody>
+      </p:sp>
+      <p:sp>
+        <p:nvSpPr>
+          <p:cNvPr id="26" name="TextBox 25"/>
+          <p:cNvSpPr txBox="1"/>
+          <p:nvPr/>
+        </p:nvSpPr>
+        <p:spPr>
+          <a:xfrm>
+            <a:off x="685800" y="2569464"/>
+            <a:ext cx="548640" cy="804672"/>
+          </a:xfrm>
+          <a:prstGeom prst="rect">
+            <a:avLst/>
+          </a:prstGeom>
+          <a:noFill/>
+        </p:spPr>
+        <p:txBody>
+          <a:bodyPr wrap="square" anchor="ctr" lIns="0" rIns="0" tIns="0" bIns="0">
+            <a:spAutoFit/>
+          </a:bodyPr>
+          <a:lstStyle/>
+          <a:p>
+            <a:pPr algn="l"/>
+            <a:r>
+              <a:rPr sz="1600" b="1">
+                <a:solidFill>
+                  <a:srgbClr val="FF2BD6"/>
+                </a:solidFill>
+                <a:latin typeface="Orbitron"/>
+              </a:rPr>
+              <a:t>02</a:t>
+            </a:r>
+          </a:p>
+        </p:txBody>
+      </p:sp>
+      <p:sp>
+        <p:nvSpPr>
+          <p:cNvPr id="27" name="TextBox 26"/>
+          <p:cNvSpPr txBox="1"/>
+          <p:nvPr/>
+        </p:nvSpPr>
+        <p:spPr>
+          <a:xfrm>
+            <a:off x="1280160" y="2615184"/>
+            <a:ext cx="7223760" cy="713232"/>
+          </a:xfrm>
+          <a:prstGeom prst="rect">
+            <a:avLst/>
+          </a:prstGeom>
+          <a:noFill/>
+        </p:spPr>
+        <p:txBody>
+          <a:bodyPr wrap="square" anchor="ctr" lIns="0" rIns="0" tIns="0" bIns="0">
+            <a:spAutoFit/>
+          </a:bodyPr>
+          <a:lstStyle/>
+          <a:p>
+            <a:pPr algn="l"/>
+            <a:r>
+              <a:rPr sz="1800" b="0">
+                <a:solidFill>
+                  <a:srgbClr val="E6F7FF"/>
+                </a:solidFill>
+                <a:latin typeface="Share Tech Mono"/>
+              </a:rPr>
+              <a:t>Ainda não há notícia de acidente aqui, e queremos que continue assim.</a:t>
+            </a:r>
+          </a:p>
+        </p:txBody>
+      </p:sp>
+      <p:sp>
+        <p:nvSpPr>
+          <p:cNvPr id="28" name="Rounded Rectangle 27"/>
+          <p:cNvSpPr/>
+          <p:nvPr/>
+        </p:nvSpPr>
+        <p:spPr>
+          <a:xfrm>
+            <a:off x="457200" y="3538728"/>
+            <a:ext cx="8229600" cy="804672"/>
+          </a:xfrm>
+          <a:prstGeom prst="roundRect">
+            <a:avLst>
+              <a:gd name="adj" fmla="val 18000"/>
+            </a:avLst>
+          </a:prstGeom>
+          <a:solidFill>
+            <a:srgbClr val="100A24">
+              <a:alpha val="85000"/>
+            </a:srgbClr>
+          </a:solidFill>
+          <a:ln w="15875">
+            <a:solidFill>
+              <a:srgbClr val="22E6FF"/>
+            </a:solidFill>
+          </a:ln>
+          <a:effectLst/>
+        </p:spPr>
+        <p:style>
+          <a:lnRef idx="1">
+            <a:schemeClr val="accent1"/>
+          </a:lnRef>
+          <a:fillRef idx="3">
+            <a:schemeClr val="accent1"/>
+          </a:fillRef>
+          <a:effectRef idx="2">
+            <a:schemeClr val="accent1"/>
+          </a:effectRef>
+          <a:fontRef idx="minor">
+            <a:schemeClr val="lt1"/>
+          </a:fontRef>
+        </p:style>
+        <p:txBody>
+          <a:bodyPr rtlCol="0" anchor="ctr"/>
+          <a:lstStyle/>
+          <a:p>
+            <a:pPr algn="ctr"/>
+          </a:p>
+        </p:txBody>
+      </p:sp>
+      <p:sp>
+        <p:nvSpPr>
+          <p:cNvPr id="29" name="TextBox 28"/>
+          <p:cNvSpPr txBox="1"/>
+          <p:nvPr/>
+        </p:nvSpPr>
+        <p:spPr>
+          <a:xfrm>
+            <a:off x="685800" y="3538728"/>
+            <a:ext cx="548640" cy="804672"/>
+          </a:xfrm>
+          <a:prstGeom prst="rect">
+            <a:avLst/>
+          </a:prstGeom>
+          <a:noFill/>
+        </p:spPr>
+        <p:txBody>
+          <a:bodyPr wrap="square" anchor="ctr" lIns="0" rIns="0" tIns="0" bIns="0">
+            <a:spAutoFit/>
+          </a:bodyPr>
+          <a:lstStyle/>
+          <a:p>
+            <a:pPr algn="l"/>
+            <a:r>
+              <a:rPr sz="1600" b="1">
+                <a:solidFill>
+                  <a:srgbClr val="FF2BD6"/>
+                </a:solidFill>
+                <a:latin typeface="Orbitron"/>
+              </a:rPr>
+              <a:t>03</a:t>
+            </a:r>
+          </a:p>
+        </p:txBody>
+      </p:sp>
+      <p:sp>
+        <p:nvSpPr>
+          <p:cNvPr id="30" name="TextBox 29"/>
+          <p:cNvSpPr txBox="1"/>
+          <p:nvPr/>
+        </p:nvSpPr>
+        <p:spPr>
+          <a:xfrm>
+            <a:off x="1280160" y="3584448"/>
+            <a:ext cx="7223760" cy="713232"/>
+          </a:xfrm>
+          <a:prstGeom prst="rect">
+            <a:avLst/>
+          </a:prstGeom>
+          <a:noFill/>
+        </p:spPr>
+        <p:txBody>
+          <a:bodyPr wrap="square" anchor="ctr" lIns="0" rIns="0" tIns="0" bIns="0">
+            <a:spAutoFit/>
+          </a:bodyPr>
+          <a:lstStyle/>
+          <a:p>
+            <a:pPr algn="l"/>
+            <a:r>
+              <a:rPr sz="1800" b="0">
+                <a:solidFill>
+                  <a:srgbClr val="E6F7FF"/>
+                </a:solidFill>
+                <a:latin typeface="Share Tech Mono"/>
+              </a:rPr>
+              <a:t>Autotec: a tecnologia de Rio do Sul a favor de quem atravessa.</a:t>
+            </a:r>
+          </a:p>
+        </p:txBody>
+      </p:sp>
+      <p:sp>
+        <p:nvSpPr>
+          <p:cNvPr id="31" name="TextBox 30"/>
+          <p:cNvSpPr txBox="1"/>
+          <p:nvPr/>
+        </p:nvSpPr>
+        <p:spPr>
+          <a:xfrm>
+            <a:off x="457200" y="4754880"/>
+            <a:ext cx="7315200" cy="228600"/>
+          </a:xfrm>
+          <a:prstGeom prst="rect">
+            <a:avLst/>
+          </a:prstGeom>
+          <a:noFill/>
+        </p:spPr>
+        <p:txBody>
+          <a:bodyPr wrap="square" anchor="t" lIns="0" rIns="0" tIns="0" bIns="0">
+            <a:spAutoFit/>
+          </a:bodyPr>
+          <a:lstStyle/>
+          <a:p>
+            <a:pPr algn="l"/>
+            <a:r>
+              <a:rPr sz="900" b="1">
+                <a:solidFill>
+                  <a:srgbClr val="22E6FF"/>
+                </a:solidFill>
+                <a:latin typeface="Orbitron"/>
+              </a:rPr>
+              <a:t>RIO DO SUL MAIS TEC</a:t>
+            </a:r>
+            <a:r>
+              <a:rPr sz="900" b="0">
+                <a:solidFill>
+                  <a:srgbClr val="8FA3C7"/>
+                </a:solidFill>
+                <a:latin typeface="Share Tech Mono"/>
+              </a:rPr>
+              <a:t>  ·  </a:t>
+            </a:r>
+            <a:r>
+              <a:rPr sz="900" b="1">
+                <a:solidFill>
+                  <a:srgbClr val="E6F7FF"/>
+                </a:solidFill>
+                <a:latin typeface="Orbitron"/>
+              </a:rPr>
+              <a:t>GOVERNO DE RIO DO SUL</a:t>
+            </a:r>
+            <a:r>
+              <a:rPr sz="900" b="0">
+                <a:solidFill>
+                  <a:srgbClr val="8FA3C7"/>
+                </a:solidFill>
+                <a:latin typeface="Share Tech Mono"/>
+              </a:rPr>
+              <a:t>  ·  </a:t>
+            </a:r>
+            <a:r>
+              <a:rPr sz="900" b="1">
+                <a:solidFill>
+                  <a:srgbClr val="FF2BD6"/>
+                </a:solidFill>
+                <a:latin typeface="Orbitron"/>
+              </a:rPr>
+              <a:t>&lt;LAB365&gt;</a:t>
+            </a:r>
+            <a:r>
+              <a:rPr sz="900" b="0">
+                <a:solidFill>
+                  <a:srgbClr val="8FA3C7"/>
+                </a:solidFill>
+                <a:latin typeface="Share Tech Mono"/>
+              </a:rPr>
+              <a:t>  ·  </a:t>
+            </a:r>
+            <a:r>
+              <a:rPr sz="900" b="1">
+                <a:solidFill>
+                  <a:srgbClr val="E6F7FF"/>
+                </a:solidFill>
+                <a:latin typeface="Orbitron"/>
+              </a:rPr>
+              <a:t>SENAI</a:t>
+            </a:r>
+            <a:r>
+              <a:rPr sz="900" b="0">
+                <a:solidFill>
+                  <a:srgbClr val="8FA3C7"/>
+                </a:solidFill>
+                <a:latin typeface="Share Tech Mono"/>
+              </a:rPr>
+              <a:t>  ·  </a:t>
+            </a:r>
+            <a:r>
+              <a:rPr sz="900" b="1">
+                <a:solidFill>
+                  <a:srgbClr val="E6F7FF"/>
+                </a:solidFill>
+                <a:latin typeface="Orbitron"/>
+              </a:rPr>
+              <a:t>SESI</a:t>
+            </a:r>
+          </a:p>
+        </p:txBody>
+      </p:sp>
+      <p:sp>
+        <p:nvSpPr>
+          <p:cNvPr id="32" name="TextBox 31"/>
+          <p:cNvSpPr txBox="1"/>
+          <p:nvPr/>
+        </p:nvSpPr>
+        <p:spPr>
+          <a:xfrm>
+            <a:off x="7772400" y="4754880"/>
+            <a:ext cx="914400" cy="228600"/>
+          </a:xfrm>
+          <a:prstGeom prst="rect">
+            <a:avLst/>
+          </a:prstGeom>
+          <a:noFill/>
+        </p:spPr>
+        <p:txBody>
+          <a:bodyPr wrap="square" anchor="t" lIns="0" rIns="0" tIns="0" bIns="0">
+            <a:spAutoFit/>
+          </a:bodyPr>
+          <a:lstStyle/>
+          <a:p>
+            <a:pPr algn="r"/>
+            <a:r>
+              <a:rPr sz="1000" b="0">
+                <a:solidFill>
+                  <a:srgbClr val="8FA3C7"/>
+                </a:solidFill>
+                <a:latin typeface="Share Tech Mono"/>
+              </a:rPr>
+              <a:t>6/6</a:t>
             </a:r>
           </a:p>
         </p:txBody>

</xml_diff>